<commit_message>
added ppt and final report
</commit_message>
<xml_diff>
--- a/docs/Data-Driven Cloth ML Mini-Project.pptx
+++ b/docs/Data-Driven Cloth ML Mini-Project.pptx
@@ -4,6 +4,9 @@
   <p:sldMasterIdLst>
     <p:sldMasterId id="2147483648" r:id="rId1"/>
   </p:sldMasterIdLst>
+  <p:notesMasterIdLst>
+    <p:notesMasterId r:id="rId15"/>
+  </p:notesMasterIdLst>
   <p:sldIdLst>
     <p:sldId id="256" r:id="rId2"/>
     <p:sldId id="257" r:id="rId3"/>
@@ -19,9 +22,6 @@
     <p:sldId id="267" r:id="rId13"/>
     <p:sldId id="268" r:id="rId14"/>
   </p:sldIdLst>
-  <p:notesMasterIdLst>
-    <p:notesMasterId r:id="rId15"/>
-  </p:notesMasterIdLst>
   <p:sldSz cx="12192000" cy="6858000"/>
   <p:notesSz cx="6858000" cy="12192000"/>
   <p:defaultTextStyle>
@@ -116,6 +116,11 @@
       </a:defRPr>
     </a:lvl9pPr>
   </p:defaultTextStyle>
+  <p:extLst>
+    <p:ext uri="{EFAFB233-063F-42B5-8137-9DF3F51BA10A}">
+      <p15:sldGuideLst xmlns:p15="http://schemas.microsoft.com/office/powerpoint/2012/main"/>
+    </p:ext>
+  </p:extLst>
 </p:presentation>
 </file>
 
@@ -141,234 +146,10 @@
           <a:chExt cx="0" cy="0"/>
         </a:xfrm>
       </p:grpSpPr>
-      <p:sp>
-        <p:nvSpPr>
-          <p:cNvPr id="2" name="Header Placeholder 1"/>
-          <p:cNvSpPr>
-            <a:spLocks noGrp="1"/>
-          </p:cNvSpPr>
-          <p:nvPr>
-            <p:ph type="hdr" sz="quarter"/>
-          </p:nvPr>
-        </p:nvSpPr>
-        <p:spPr>
-          <a:xfrm>
-            <a:off x="0" y="0"/>
-            <a:ext cx="2971800" cy="458788"/>
-          </a:xfrm>
-          <a:prstGeom prst="rect">
-            <a:avLst/>
-          </a:prstGeom>
-        </p:spPr>
-        <p:txBody>
-          <a:bodyPr vert="horz" lIns="91440" tIns="45720" rIns="91440" bIns="45720" rtlCol="0"/>
-          <a:lstStyle>
-            <a:lvl1pPr algn="l">
-              <a:defRPr sz="1200"/>
-            </a:lvl1pPr>
-          </a:lstStyle>
-          <a:p>
-            <a:endParaRPr lang="en-US"/>
-          </a:p>
-        </p:txBody>
-      </p:sp>
-      <p:sp>
-        <p:nvSpPr>
-          <p:cNvPr id="3" name="Date Placeholder 2"/>
-          <p:cNvSpPr>
-            <a:spLocks noGrp="1"/>
-          </p:cNvSpPr>
-          <p:nvPr>
-            <p:ph type="dt" idx="1"/>
-          </p:nvPr>
-        </p:nvSpPr>
-        <p:spPr>
-          <a:xfrm>
-            <a:off x="3884613" y="0"/>
-            <a:ext cx="2971800" cy="458788"/>
-          </a:xfrm>
-          <a:prstGeom prst="rect">
-            <a:avLst/>
-          </a:prstGeom>
-        </p:spPr>
-        <p:txBody>
-          <a:bodyPr vert="horz" lIns="91440" tIns="45720" rIns="91440" bIns="45720" rtlCol="0"/>
-          <a:lstStyle>
-            <a:lvl1pPr algn="r">
-              <a:defRPr sz="1200"/>
-            </a:lvl1pPr>
-          </a:lstStyle>
-          <a:p>
-            <a:fld id="{5282F153-3F37-0F45-9E97-73ACFA13230C}" type="datetimeFigureOut">
-              <a:rPr lang="en-US"/>
-              <a:t>7/23/19</a:t>
-            </a:fld>
-            <a:endParaRPr lang="en-US"/>
-          </a:p>
-        </p:txBody>
-      </p:sp>
-      <p:sp>
-        <p:nvSpPr>
-          <p:cNvPr id="4" name="Slide Image Placeholder 3"/>
-          <p:cNvSpPr>
-            <a:spLocks noGrp="1" noRot="1" noChangeAspect="1"/>
-          </p:cNvSpPr>
-          <p:nvPr>
-            <p:ph type="sldImg" idx="2"/>
-          </p:nvPr>
-        </p:nvSpPr>
-        <p:spPr>
-          <a:xfrm>
-            <a:off x="685800" y="1143000"/>
-            <a:ext cx="5486400" cy="3086100"/>
-          </a:xfrm>
-          <a:prstGeom prst="rect">
-            <a:avLst/>
-          </a:prstGeom>
-          <a:noFill/>
-          <a:ln w="12700">
-            <a:solidFill>
-              <a:prstClr val="black"/>
-            </a:solidFill>
-          </a:ln>
-        </p:spPr>
-        <p:txBody>
-          <a:bodyPr vert="horz" lIns="91440" tIns="45720" rIns="91440" bIns="45720" rtlCol="0" anchor="ctr"/>
-          <a:lstStyle/>
-          <a:p>
-            <a:endParaRPr lang="en-US"/>
-          </a:p>
-        </p:txBody>
-      </p:sp>
-      <p:sp>
-        <p:nvSpPr>
-          <p:cNvPr id="5" name="Notes Placeholder 4"/>
-          <p:cNvSpPr>
-            <a:spLocks noGrp="1"/>
-          </p:cNvSpPr>
-          <p:nvPr>
-            <p:ph type="body" sz="quarter" idx="3"/>
-          </p:nvPr>
-        </p:nvSpPr>
-        <p:spPr>
-          <a:xfrm>
-            <a:off x="685800" y="4400550"/>
-            <a:ext cx="5486400" cy="3600450"/>
-          </a:xfrm>
-          <a:prstGeom prst="rect">
-            <a:avLst/>
-          </a:prstGeom>
-        </p:spPr>
-        <p:txBody>
-          <a:bodyPr vert="horz" lIns="91440" tIns="45720" rIns="91440" bIns="45720" rtlCol="0"/>
-          <a:lstStyle/>
-          <a:p>
-            <a:pPr lvl="0"/>
-            <a:r>
-              <a:rPr lang="en-US"/>
-              <a:t>Click to edit Master text styles</a:t>
-            </a:r>
-          </a:p>
-          <a:p>
-            <a:pPr lvl="1"/>
-            <a:r>
-              <a:rPr lang="en-US"/>
-              <a:t>Second level</a:t>
-            </a:r>
-          </a:p>
-          <a:p>
-            <a:pPr lvl="2"/>
-            <a:r>
-              <a:rPr lang="en-US"/>
-              <a:t>Third level</a:t>
-            </a:r>
-          </a:p>
-          <a:p>
-            <a:pPr lvl="3"/>
-            <a:r>
-              <a:rPr lang="en-US"/>
-              <a:t>Fourth level</a:t>
-            </a:r>
-          </a:p>
-          <a:p>
-            <a:pPr lvl="4"/>
-            <a:r>
-              <a:rPr lang="en-US"/>
-              <a:t>Fifth level</a:t>
-            </a:r>
-          </a:p>
-        </p:txBody>
-      </p:sp>
-      <p:sp>
-        <p:nvSpPr>
-          <p:cNvPr id="6" name="Footer Placeholder 5"/>
-          <p:cNvSpPr>
-            <a:spLocks noGrp="1"/>
-          </p:cNvSpPr>
-          <p:nvPr>
-            <p:ph type="ftr" sz="quarter" idx="4"/>
-          </p:nvPr>
-        </p:nvSpPr>
-        <p:spPr>
-          <a:xfrm>
-            <a:off x="0" y="8685213"/>
-            <a:ext cx="2971800" cy="458787"/>
-          </a:xfrm>
-          <a:prstGeom prst="rect">
-            <a:avLst/>
-          </a:prstGeom>
-        </p:spPr>
-        <p:txBody>
-          <a:bodyPr vert="horz" lIns="91440" tIns="45720" rIns="91440" bIns="45720" rtlCol="0" anchor="b"/>
-          <a:lstStyle>
-            <a:lvl1pPr algn="l">
-              <a:defRPr sz="1200"/>
-            </a:lvl1pPr>
-          </a:lstStyle>
-          <a:p>
-            <a:endParaRPr lang="en-US"/>
-          </a:p>
-        </p:txBody>
-      </p:sp>
-      <p:sp>
-        <p:nvSpPr>
-          <p:cNvPr id="7" name="Slide Number Placeholder 6"/>
-          <p:cNvSpPr>
-            <a:spLocks noGrp="1"/>
-          </p:cNvSpPr>
-          <p:nvPr>
-            <p:ph type="sldNum" sz="quarter" idx="5"/>
-          </p:nvPr>
-        </p:nvSpPr>
-        <p:spPr>
-          <a:xfrm>
-            <a:off x="3884613" y="8685213"/>
-            <a:ext cx="2971800" cy="458787"/>
-          </a:xfrm>
-          <a:prstGeom prst="rect">
-            <a:avLst/>
-          </a:prstGeom>
-        </p:spPr>
-        <p:txBody>
-          <a:bodyPr vert="horz" lIns="91440" tIns="45720" rIns="91440" bIns="45720" rtlCol="0" anchor="b"/>
-          <a:lstStyle>
-            <a:lvl1pPr algn="r">
-              <a:defRPr sz="1200"/>
-            </a:lvl1pPr>
-          </a:lstStyle>
-          <a:p>
-            <a:fld id="{CE5E9CC1-C706-0F49-92D6-E571CC5EEA8F}" type="slidenum">
-              <a:rPr lang="en-US"/>
-              <a:t>‹#›</a:t>
-            </a:fld>
-            <a:endParaRPr lang="en-US"/>
-          </a:p>
-        </p:txBody>
-      </p:sp>
     </p:spTree>
     <p:extLst>
       <p:ext uri="{BB962C8B-B14F-4D97-AF65-F5344CB8AC3E}">
-        <p14:creationId xmlns:p14="http://schemas.microsoft.com/office/powerpoint/2010/main" val="1024086991"/>
+        <p14:creationId xmlns:p14="http://schemas.microsoft.com/office/powerpoint/2010/main" val="3931672236"/>
       </p:ext>
     </p:extLst>
   </p:cSld>
@@ -516,7 +297,6 @@
               <a:rPr lang="en-US" dirty="0"/>
               <a:t>Suggested presenter: Tejas. Introduce yourselves and the project in one sentence: we reproduced a research paper (Xue and Wu, Stanford CS229, 2021) on predicting how clothing deforms from a character's pose with a neural network, using the public TailorNet garment data. About 8 to 10 minutes plus the live demo and Q&amp;A. Structure: the topic, the original paper, what we did, the problem statement, the dataset, the approach, the implementation, then demo, results and conclusions.</a:t>
             </a:r>
-            <a:endParaRPr lang="en-US" dirty="0"/>
           </a:p>
         </p:txBody>
       </p:sp>
@@ -604,7 +384,6 @@
               <a:rPr lang="en-US" dirty="0"/>
               <a:t>Suggested presenter: Tejas. Before the review starts, run python demo.py --model tn_pca128 --compare tn_linreg --data data/tailornet.npz and keep the window open. The garment is drawn as a point cloud. Left to right: the real simulated garment, the PCA-128 prediction, the linear-regression prediction, and the error map of the PCA-128 prediction. Use the left and right arrow keys to step through test poses and show three or four of them; the mouse rotates the 3D view. The numbers on the next slide show the difference between the models. If the window fails to open, run the same command with --save results/demo.png --no_show --index 7 to make an image.</a:t>
             </a:r>
-            <a:endParaRPr lang="en-US" dirty="0"/>
           </a:p>
         </p:txBody>
       </p:sp>
@@ -692,7 +471,6 @@
               <a:rPr lang="en-US" dirty="0"/>
               <a:t>Suggested presenter: Tejas (evaluate.py produces these numbers and plots). Test set of 749 poses, seed 0. Predicting the training mean gives an MSE of 1.868; linear regression 0.907; the direct network 0.379 and the three PCA networks 0.403 to 0.410 after 1,000 epochs, which is 55 to 58 percent lower than linear regression. The best network is 2.4 times better than linear regression; the paper reports 2.6 times. After only 200 epochs the networks were at 0.475 (direct) and 0.66 (PCA), so training length matters, especially for the PCA networks: the gap between PCA and direct shrank from about 39 percent to 6 to 8 percent. The training curve shows why: the direct network has levelled off (best epoch 909) while the PCA networks are still slowly improving at epoch 1,000, so more training might close the rest of the gap (we did not test this). The paper found PCA about 6 percent better than direct; we did not reproduce that, and we say so. The three values of k differ by less than 2 percent, which is within single-run noise, so we do not claim a best k. Prediction takes about 0.015 to 0.064 ms per pose when predicting 256 poses at a time on a CPU; single-pose timings were 0.3 to 2.1 ms and noisy. Likely question: what is vertex error? Answer: the mean Euclidean distance, in cm, between the predicted and the true position of each garment vertex.</a:t>
             </a:r>
-            <a:endParaRPr lang="en-US" dirty="0"/>
           </a:p>
         </p:txBody>
       </p:sp>
@@ -780,7 +558,6 @@
               <a:rPr lang="en-US" dirty="0"/>
               <a:t>Suggested presenter: Mukesh (pca.py computes this). Left plot: cumulative explained variance of the offsets against the number of components; it rises steeply and passes 95 percent at around 60 components. Right plot: the reconstruction error that even a perfect predictor would still have, on the test set; it is about 0.075 at 64 components, 0.045 at 128 and 0.026 at 256, compared with a model error of about 0.4, so PCA is not what limits accuracy. The trade-off, from the results slide: with 64 components the network has 60.6 thousand trainable parameters against 2.13 million for direct prediction, 35 times fewer (19 times fewer with 256 components), at a test MSE about 8 percent higher (0.410 versus 0.379). Be upfront that the paper found PCA slightly better than direct, and we did not reproduce that. Likely question: why is PCA worse here? Answer: we are not sure; the PCA networks were still improving at epoch 1,000 while the direct network had levelled off, and the gap shrank from 39 percent at 200 epochs to 6 to 8 percent, so it may be a matter of training length, which we did not test. Another: which k is best? Answer: more components were slightly better, but the three results differ by less than 2 percent, which is within single-run noise. The values for the reconstruction error are read from the plot, so say 'about'.</a:t>
             </a:r>
-            <a:endParaRPr lang="en-US" dirty="0"/>
           </a:p>
         </p:txBody>
       </p:sp>
@@ -868,7 +645,6 @@
               <a:rPr lang="en-US" dirty="0"/>
               <a:t>Suggested presenter: Tejas. Summarise the three findings, then how they compare with the paper. Learned models clearly beat linear regression: test MSE falls from 0.907 to between 0.379 and 0.410, and the best network is 2.4 times better, close to the paper's 2.6 times. PCA gives a much smaller network, 19 to 35 times fewer trainable parameters, at a small cost in accuracy, 6 to 8 percent. The paper found PCA about 6 percent better than direct prediction and 128 components best; we did not reproduce either: direct was best, and the three values of k are within 2 percent of each other, which is within single-run noise. The PCA networks were still improving at epoch 1,000, so longer training might change this; we did not test it. Limitations to state yourselves: one garment, one random seed, 3.7 thousand poses against the paper's 10 thousand, and a random split, so test poses share body shapes and styles with training. Future work: several seeds, longer training, and a split by body shape. Then invite questions.</a:t>
             </a:r>
-            <a:endParaRPr lang="en-US" dirty="0"/>
           </a:p>
         </p:txBody>
       </p:sp>
@@ -956,7 +732,6 @@
               <a:rPr lang="en-US" dirty="0"/>
               <a:t>Suggested presenter: Tejas. Explain the topic in plain words. Clothes on a moving character can be produced three ways. A physics simulation solves the cloth's equations step by step: very realistic but slow (the paper reports about 180 seconds for one coat). Skinning attaches the cloth to the skeleton: instant, but the cloth looks stiff. The data-driven idea is to run the slow simulation offline for many poses, then train a model that predicts the simulated cloth from the pose, so it runs in milliseconds. Our project implements and tests this third approach.</a:t>
             </a:r>
-            <a:endParaRPr lang="en-US" dirty="0"/>
           </a:p>
         </p:txBody>
       </p:sp>
@@ -1044,7 +819,6 @@
               <a:rPr lang="en-US" dirty="0"/>
               <a:t>Suggested presenter: Tejas. The paper is a Stanford CS229 project report by Kangrui Xue and Jane Wu. They simulated 10,000 poses of a coat with Blender (skinning) and PhysBAM (cloth simulation). A fully connected network takes the 14 joint quaternions (56 numbers) and predicts PCA coefficients of the coat's vertex offsets; a fixed PCA layer turns them into the 6,510 offsets (2,170 vertices times 3). They compared predicting the offsets directly, 256, 128 and 64 PCA components, and a linear regression baseline. Their best model used 128 components with a test cost of 1.50e-4, about 2.6 times lower than the linear baseline at 3.83e-4. The network predicts in about 0.1 ms on a GPU, versus about 180 s for the procedural simulator on a CPU.</a:t>
             </a:r>
-            <a:endParaRPr lang="en-US" dirty="0"/>
           </a:p>
         </p:txBody>
       </p:sp>
@@ -1132,7 +906,6 @@
               <a:rPr lang="en-US" dirty="0"/>
               <a:t>Suggested presenter: Tejas. Give the four steps in one breath. We used the public TailorNet dataset of simulated garments (the paper's own data is not available), implemented PCA, the neural network and the linear baseline in PyTorch, ran the same ablation as the paper (predict the offsets directly, or 256, 128 or 64 PCA components), trained for 200 and for 1,000 epochs, and then evaluated on a held-out test set, produced plots and built a live demo. The next slides go through each part in the order of the written report: problem statement, dataset, approach, implementation, then results and conclusions.</a:t>
             </a:r>
-            <a:endParaRPr lang="en-US" dirty="0"/>
           </a:p>
         </p:txBody>
       </p:sp>
@@ -1220,7 +993,6 @@
               <a:rPr lang="en-US" dirty="0"/>
               <a:t>Suggested presenter: Tejas. This is a supervised regression problem. The input is the pose (72 SMPL numbers) plus the body shape (10) and garment style (4), 86 numbers in all; the paper used 14 joint quaternions, 56 numbers, for one coat. The output is, for every garment vertex, the offset from the rest garment, 3 numbers per vertex; for our short pants that is 2,710 vertices, 8,130 numbers. The goal is to learn this map with a neural network, so a prediction takes milliseconds, and to compare it with a linear regression baseline.</a:t>
             </a:r>
-            <a:endParaRPr lang="en-US" dirty="0"/>
           </a:p>
         </p:txBody>
       </p:sp>
@@ -1308,7 +1080,6 @@
               <a:rPr lang="en-US" dirty="0"/>
               <a:t>Suggested presenter: Tejas. The paper's coat dataset (Blender skinning plus PhysBAM simulation) is not publicly available, so we use TailorNet (Patel et al., CVPR 2020), a public dataset of simulated garments on SMPL bodies. We use its male short-pants garment: 2,710 vertices, so 8,130 outputs. From the 40 body-shape and garment-style combinations in the download we sampled up to 100 poses each, 3,833 poses in all. The target for each pose is the simulated garment minus the rest garment of that shape and style, in cm (mean offset 1.98 cm per vertex, maximum 38.6 cm). As in the paper we remove implausible examples with a distance threshold: largest vertex offset above median plus 5 robust standard deviations, 19.8 cm, which removed 91 poses. The remaining 3,742 are split at random into 2,245 train, 748 validation and 749 test; PCA is fitted on training data only. Because poses from different bodies and styles are mixed, the input also includes shape (10) and style (4), so 86 numbers instead of the paper's 56. Likely question: are the removed poses really faulty? Answer: we used a distance threshold like the paper; we did not inspect them one by one. Another: do test poses come from unseen bodies? No, the split is random, so test poses share body shapes and styles with training.</a:t>
             </a:r>
-            <a:endParaRPr lang="en-US" dirty="0"/>
           </a:p>
         </p:txBody>
       </p:sp>
@@ -1396,7 +1167,6 @@
               <a:rPr lang="en-US" dirty="0"/>
               <a:t>Suggested presenter: Mukesh (this is the part his modules pca.py and model.py implement). Walk left to right. The MLP has two hidden ReLU layers (128 and 256 units) and outputs k PCA coefficients; its input is the 86 numbers (pose, shape, style). The PCA layer is a fixed linear layer built from the top-k principal components of the training offsets plus the mean, so the loss is the mean squared error on the reconstructed vertex offsets. PCA reduces the output from 8,130 numbers to k. Training uses Adam, learning rate 1e-4, batch size 32; we trained every model for 200 epochs and again for 1,000 epochs, the paper's setting; we keep the checkpoint with the best validation loss. The baseline is linear regression, which is a network with no hidden layers; we solve it in closed form by least squares. The ablation compares predicting the offsets directly with k = 256, 128 and 64. Likely question: why PCA? Answer: cloth offsets are strongly correlated across vertices, so a few components describe them; it makes the output layer and the model much smaller and acts as a regulariser.</a:t>
             </a:r>
-            <a:endParaRPr lang="en-US" dirty="0"/>
           </a:p>
         </p:txBody>
       </p:sp>
@@ -1484,7 +1254,6 @@
               <a:rPr lang="en-US" dirty="0"/>
               <a:t>Suggested presenter: Mukesh (model.py). Walk through the diagram left to right. Input: 86 numbers, which are the SMPL pose (72), the body shape (10) and the garment style (4). Hidden layer 1 has 128 neurons and hidden layer 2 has 256 neurons, both with ReLU. The last trained layer outputs k PCA coefficients, with k equal to 64, 128 or 256 depending on the model. Then comes the fixed PCA layer: it is not trained, its weights are the top-k principal components and the mean of the training offsets, and it turns the k coefficients into the 8,130 outputs, which are 2,710 garment vertices times 3 coordinates. The loss is the mean squared error on those 8,130 values. Parameter count for k = 64: 86 times 128 plus 128 is 11,136; 128 times 256 plus 256 is 33,024; 256 times 64 plus 64 is 16,448; total 60,608 trainable parameters. For k = 128 the total is 77,056 and for k = 256 it is 109,952. The direct model skips the PCA layer and its last layer maps 256 neurons straight to 8,130 outputs, which gives 2,133,570 parameters. Only five circles are drawn per layer; the dots mean there are more. Likely question: why is the PCA layer fixed? Answer: it is computed from the data first, so the network only has to learn the k coefficients.</a:t>
             </a:r>
-            <a:endParaRPr lang="en-US" dirty="0"/>
           </a:p>
         </p:txBody>
       </p:sp>
@@ -1572,7 +1341,6 @@
               <a:rPr lang="en-US" dirty="0"/>
               <a:t>Both presenters. Suggested split: Tejas covers data_tailornet.py, train.py, evaluate.py and demo.py; Mukesh covers pca.py and model.py. Mention that the repository is private and shared with the faculty, that the README has setup and run commands, and that run_all_tn.bat builds the dataset from the TailorNet download, trains all models and produces the plots and results table. Mukesh's files in one sentence each: pca.py fits PCA with an SVD on the training offsets and gives the top-k components; model.py defines the MLP whose last step is a fixed linear layer built from those components, plus the closed-form linear baseline. evaluate.py (Tejas) loads each trained model, computes test error, per-vertex error and timing, and draws the plots.</a:t>
             </a:r>
-            <a:endParaRPr lang="en-US" dirty="0"/>
           </a:p>
         </p:txBody>
       </p:sp>
@@ -1650,6 +1418,7 @@
         <a:solidFill>
           <a:srgbClr val="F6F4EE"/>
         </a:solidFill>
+        <a:effectLst/>
       </p:bgPr>
     </p:bg>
     <p:spTree>
@@ -1669,7 +1438,9 @@
       <p:sp>
         <p:nvSpPr>
           <p:cNvPr id="2" name="Title Placeholder 1"/>
-          <p:cNvSpPr/>
+          <p:cNvSpPr>
+            <a:spLocks noGrp="1"/>
+          </p:cNvSpPr>
           <p:nvPr>
             <p:ph type="title"/>
           </p:nvPr>
@@ -1688,7 +1459,7 @@
         <p:txBody>
           <a:bodyPr wrap="square" lIns="0" tIns="0" rIns="0" bIns="0" rtlCol="0" anchor="t"/>
           <a:lstStyle>
-            <a:lvl1pPr algn="l" indent="0" marL="0">
+            <a:lvl1pPr marL="0" indent="0" algn="l">
               <a:lnSpc>
                 <a:spcPct val="115000"/>
               </a:lnSpc>
@@ -1704,7 +1475,7 @@
             </a:lvl1pPr>
           </a:lstStyle>
           <a:p>
-            <a:pPr algn="l" indent="0" marL="0">
+            <a:pPr marL="0" indent="0" algn="l">
               <a:lnSpc>
                 <a:spcPct val="115000"/>
               </a:lnSpc>
@@ -1717,9 +1488,11 @@
       <p:sp>
         <p:nvSpPr>
           <p:cNvPr id="3" name="Text Placeholder 2"/>
-          <p:cNvSpPr/>
+          <p:cNvSpPr>
+            <a:spLocks noGrp="1"/>
+          </p:cNvSpPr>
           <p:nvPr>
-            <p:ph idx="101" type="body"/>
+            <p:ph type="body" idx="101"/>
           </p:nvPr>
         </p:nvSpPr>
         <p:spPr>
@@ -1736,7 +1509,7 @@
         <p:txBody>
           <a:bodyPr wrap="square" lIns="0" tIns="0" rIns="0" bIns="0" rtlCol="0" anchor="t"/>
           <a:lstStyle>
-            <a:lvl1pPr algn="l" indent="0" marL="0">
+            <a:lvl1pPr marL="0" indent="0" algn="l">
               <a:lnSpc>
                 <a:spcPct val="140000"/>
               </a:lnSpc>
@@ -1752,7 +1525,7 @@
             </a:lvl1pPr>
           </a:lstStyle>
           <a:p>
-            <a:pPr algn="l" indent="0" marL="0">
+            <a:pPr marL="0" indent="0" algn="l">
               <a:lnSpc>
                 <a:spcPct val="140000"/>
               </a:lnSpc>
@@ -1778,6 +1551,7 @@
         <a:solidFill>
           <a:srgbClr val="F6F4EE"/>
         </a:solidFill>
+        <a:effectLst/>
       </p:bgPr>
     </p:bg>
     <p:spTree>
@@ -1797,7 +1571,9 @@
       <p:sp>
         <p:nvSpPr>
           <p:cNvPr id="2" name="Title Placeholder 1"/>
-          <p:cNvSpPr/>
+          <p:cNvSpPr>
+            <a:spLocks noGrp="1"/>
+          </p:cNvSpPr>
           <p:nvPr>
             <p:ph type="title"/>
           </p:nvPr>
@@ -1816,7 +1592,7 @@
         <p:txBody>
           <a:bodyPr wrap="square" lIns="0" tIns="0" rIns="0" bIns="0" rtlCol="0" anchor="t"/>
           <a:lstStyle>
-            <a:lvl1pPr algn="l" indent="0" marL="0">
+            <a:lvl1pPr marL="0" indent="0" algn="l">
               <a:lnSpc>
                 <a:spcPct val="115000"/>
               </a:lnSpc>
@@ -1832,7 +1608,7 @@
             </a:lvl1pPr>
           </a:lstStyle>
           <a:p>
-            <a:pPr algn="l" indent="0" marL="0">
+            <a:pPr marL="0" indent="0" algn="l">
               <a:lnSpc>
                 <a:spcPct val="115000"/>
               </a:lnSpc>
@@ -1845,9 +1621,11 @@
       <p:sp>
         <p:nvSpPr>
           <p:cNvPr id="3" name="Text Placeholder 2"/>
-          <p:cNvSpPr/>
+          <p:cNvSpPr>
+            <a:spLocks noGrp="1"/>
+          </p:cNvSpPr>
           <p:nvPr>
-            <p:ph idx="101" type="body"/>
+            <p:ph type="body" idx="101"/>
           </p:nvPr>
         </p:nvSpPr>
         <p:spPr>
@@ -1864,7 +1642,7 @@
         <p:txBody>
           <a:bodyPr wrap="square" lIns="0" tIns="0" rIns="0" bIns="0" rtlCol="0" anchor="t"/>
           <a:lstStyle>
-            <a:lvl1pPr algn="l" indent="0" marL="0">
+            <a:lvl1pPr marL="0" indent="0" algn="l">
               <a:lnSpc>
                 <a:spcPct val="140000"/>
               </a:lnSpc>
@@ -1880,7 +1658,7 @@
             </a:lvl1pPr>
           </a:lstStyle>
           <a:p>
-            <a:pPr algn="l" indent="0" marL="0">
+            <a:pPr marL="0" indent="0" algn="l">
               <a:lnSpc>
                 <a:spcPct val="140000"/>
               </a:lnSpc>
@@ -2159,6 +1937,7 @@
         <a:solidFill>
           <a:srgbClr val="14213D"/>
         </a:solidFill>
+        <a:effectLst/>
       </p:bgPr>
     </p:bg>
     <p:spTree>
@@ -2198,14 +1977,14 @@
           </a:bodyPr>
           <a:lstStyle/>
           <a:p>
-            <a:pPr algn="l" indent="0" marL="0">
+            <a:pPr marL="0" indent="0" algn="l">
               <a:lnSpc>
                 <a:spcPts val="1680"/>
               </a:lnSpc>
               <a:buNone/>
             </a:pPr>
             <a:r>
-              <a:rPr lang="en-US" sz="1200" b="1" spc="100" kern="0" dirty="0">
+              <a:rPr lang="en-US" sz="1200" b="1" kern="0" spc="100" dirty="0">
                 <a:solidFill>
                   <a:srgbClr val="E9B44C"/>
                 </a:solidFill>
@@ -2222,7 +2001,9 @@
       <p:sp>
         <p:nvSpPr>
           <p:cNvPr id="3" name="Text 1"/>
-          <p:cNvSpPr/>
+          <p:cNvSpPr>
+            <a:spLocks noGrp="1"/>
+          </p:cNvSpPr>
           <p:nvPr>
             <p:ph type="title"/>
           </p:nvPr>
@@ -2244,7 +2025,7 @@
           </a:bodyPr>
           <a:lstStyle/>
           <a:p>
-            <a:pPr algn="l" indent="0" marL="0">
+            <a:pPr marL="0" indent="0" algn="l">
               <a:lnSpc>
                 <a:spcPts val="5280"/>
               </a:lnSpc>
@@ -2288,7 +2069,7 @@
           </a:bodyPr>
           <a:lstStyle/>
           <a:p>
-            <a:pPr algn="l" indent="0" marL="0">
+            <a:pPr marL="0" indent="0" algn="l">
               <a:lnSpc>
                 <a:spcPts val="2340"/>
               </a:lnSpc>
@@ -2332,7 +2113,7 @@
           </a:bodyPr>
           <a:lstStyle/>
           <a:p>
-            <a:pPr algn="l" indent="0" marL="0">
+            <a:pPr marL="0" indent="0" algn="l">
               <a:lnSpc>
                 <a:spcPts val="2100"/>
               </a:lnSpc>
@@ -2347,7 +2128,7 @@
                 <a:ea typeface="IBM Plex Sans" pitchFamily="34" charset="-122"/>
                 <a:cs typeface="IBM Plex Sans" pitchFamily="34" charset="-120"/>
               </a:rPr>
-              <a:t>Tejas Ponnappa · PES1UG24CS498  |  Mukesh Sheregar · PES1UG24CS828</a:t>
+              <a:t>Tejas Ponnappa · PES1UG24CS498  |  Mukesh Sheregar · PES1UG25CS828</a:t>
             </a:r>
             <a:endParaRPr lang="en-US" sz="1500" dirty="0"/>
           </a:p>
@@ -2369,6 +2150,7 @@
         <a:solidFill>
           <a:srgbClr val="F6F4EE"/>
         </a:solidFill>
+        <a:effectLst/>
       </p:bgPr>
     </p:bg>
     <p:spTree>
@@ -2408,14 +2190,14 @@
           </a:bodyPr>
           <a:lstStyle/>
           <a:p>
-            <a:pPr algn="l" indent="0" marL="0">
+            <a:pPr marL="0" indent="0" algn="l">
               <a:lnSpc>
                 <a:spcPts val="1680"/>
               </a:lnSpc>
               <a:buNone/>
             </a:pPr>
             <a:r>
-              <a:rPr lang="en-US" sz="1200" b="1" spc="100" kern="0" dirty="0">
+              <a:rPr lang="en-US" sz="1200" b="1" kern="0" spc="100" dirty="0">
                 <a:solidFill>
                   <a:srgbClr val="17757A"/>
                 </a:solidFill>
@@ -2432,7 +2214,9 @@
       <p:sp>
         <p:nvSpPr>
           <p:cNvPr id="3" name="Text 1"/>
-          <p:cNvSpPr/>
+          <p:cNvSpPr>
+            <a:spLocks noGrp="1"/>
+          </p:cNvSpPr>
           <p:nvPr>
             <p:ph type="title"/>
           </p:nvPr>
@@ -2454,7 +2238,7 @@
           </a:bodyPr>
           <a:lstStyle/>
           <a:p>
-            <a:pPr algn="l" indent="0" marL="0">
+            <a:pPr marL="0" indent="0" algn="l">
               <a:lnSpc>
                 <a:spcPts val="3080"/>
               </a:lnSpc>
@@ -2525,7 +2309,7 @@
           </a:bodyPr>
           <a:lstStyle/>
           <a:p>
-            <a:pPr algn="l" indent="0" marL="0">
+            <a:pPr marL="0" indent="0" algn="l">
               <a:lnSpc>
                 <a:spcPts val="2160"/>
               </a:lnSpc>
@@ -2569,7 +2353,7 @@
           </a:bodyPr>
           <a:lstStyle/>
           <a:p>
-            <a:pPr algn="l" marL="182880" indent="-182880">
+            <a:pPr marL="182880" indent="-182880" algn="l">
               <a:lnSpc>
                 <a:spcPts val="2250"/>
               </a:lnSpc>
@@ -2590,7 +2374,7 @@
             <a:endParaRPr lang="en-US" sz="1500" dirty="0"/>
           </a:p>
           <a:p>
-            <a:pPr algn="l" marL="182880" indent="-182880">
+            <a:pPr marL="182880" indent="-182880" algn="l">
               <a:lnSpc>
                 <a:spcPts val="2250"/>
               </a:lnSpc>
@@ -2611,7 +2395,7 @@
             <a:endParaRPr lang="en-US" sz="1500" dirty="0"/>
           </a:p>
           <a:p>
-            <a:pPr algn="l" marL="182880" indent="-182880">
+            <a:pPr marL="182880" indent="-182880" algn="l">
               <a:lnSpc>
                 <a:spcPts val="2250"/>
               </a:lnSpc>
@@ -2632,7 +2416,7 @@
             <a:endParaRPr lang="en-US" sz="1500" dirty="0"/>
           </a:p>
           <a:p>
-            <a:pPr algn="l" marL="182880" indent="-182880">
+            <a:pPr marL="182880" indent="-182880" algn="l">
               <a:lnSpc>
                 <a:spcPts val="2250"/>
               </a:lnSpc>
@@ -2699,7 +2483,7 @@
           </a:bodyPr>
           <a:lstStyle/>
           <a:p>
-            <a:pPr algn="l" indent="0" marL="0">
+            <a:pPr marL="0" indent="0" algn="l">
               <a:lnSpc>
                 <a:spcPts val="2160"/>
               </a:lnSpc>
@@ -2743,7 +2527,7 @@
           </a:bodyPr>
           <a:lstStyle/>
           <a:p>
-            <a:pPr algn="l" marL="182880" indent="-182880">
+            <a:pPr marL="182880" indent="-182880" algn="l">
               <a:lnSpc>
                 <a:spcPts val="2250"/>
               </a:lnSpc>
@@ -2764,7 +2548,7 @@
             <a:endParaRPr lang="en-US" sz="1500" dirty="0"/>
           </a:p>
           <a:p>
-            <a:pPr algn="l" marL="182880" indent="-182880">
+            <a:pPr marL="182880" indent="-182880" algn="l">
               <a:lnSpc>
                 <a:spcPts val="2250"/>
               </a:lnSpc>
@@ -2785,7 +2569,7 @@
             <a:endParaRPr lang="en-US" sz="1500" dirty="0"/>
           </a:p>
           <a:p>
-            <a:pPr algn="l" marL="182880" indent="-182880">
+            <a:pPr marL="182880" indent="-182880" algn="l">
               <a:lnSpc>
                 <a:spcPts val="2250"/>
               </a:lnSpc>
@@ -2830,7 +2614,7 @@
           </a:bodyPr>
           <a:lstStyle/>
           <a:p>
-            <a:pPr algn="l" indent="0" marL="0">
+            <a:pPr marL="0" indent="0" algn="l">
               <a:lnSpc>
                 <a:spcPts val="2100"/>
               </a:lnSpc>
@@ -2874,7 +2658,7 @@
           </a:bodyPr>
           <a:lstStyle/>
           <a:p>
-            <a:pPr algn="l" indent="0" marL="0">
+            <a:pPr marL="0" indent="0" algn="l">
               <a:lnSpc>
                 <a:spcPts val="1680"/>
               </a:lnSpc>
@@ -2918,7 +2702,7 @@
           </a:bodyPr>
           <a:lstStyle/>
           <a:p>
-            <a:pPr algn="r" indent="0" marL="0">
+            <a:pPr marL="0" indent="0" algn="r">
               <a:lnSpc>
                 <a:spcPts val="1680"/>
               </a:lnSpc>
@@ -2955,6 +2739,7 @@
         <a:solidFill>
           <a:srgbClr val="F6F4EE"/>
         </a:solidFill>
+        <a:effectLst/>
       </p:bgPr>
     </p:bg>
     <p:spTree>
@@ -2994,14 +2779,14 @@
           </a:bodyPr>
           <a:lstStyle/>
           <a:p>
-            <a:pPr algn="l" indent="0" marL="0">
+            <a:pPr marL="0" indent="0" algn="l">
               <a:lnSpc>
                 <a:spcPts val="1680"/>
               </a:lnSpc>
               <a:buNone/>
             </a:pPr>
             <a:r>
-              <a:rPr lang="en-US" sz="1200" b="1" spc="100" kern="0" dirty="0">
+              <a:rPr lang="en-US" sz="1200" b="1" kern="0" spc="100" dirty="0">
                 <a:solidFill>
                   <a:srgbClr val="17757A"/>
                 </a:solidFill>
@@ -3018,7 +2803,9 @@
       <p:sp>
         <p:nvSpPr>
           <p:cNvPr id="3" name="Text 1"/>
-          <p:cNvSpPr/>
+          <p:cNvSpPr>
+            <a:spLocks noGrp="1"/>
+          </p:cNvSpPr>
           <p:nvPr>
             <p:ph type="title"/>
           </p:nvPr>
@@ -3040,7 +2827,7 @@
           </a:bodyPr>
           <a:lstStyle/>
           <a:p>
-            <a:pPr algn="l" indent="0" marL="0">
+            <a:pPr marL="0" indent="0" algn="l">
               <a:lnSpc>
                 <a:spcPts val="3080"/>
               </a:lnSpc>
@@ -3077,18 +2864,48 @@
         </p:nvGraphicFramePr>
         <p:xfrm>
           <a:off x="824327" y="1758967"/>
-          <a:ext cx="5957454" cy="2942377"/>
+          <a:ext cx="5957455" cy="2942375"/>
         </p:xfrm>
         <a:graphic>
           <a:graphicData uri="http://schemas.openxmlformats.org/drawingml/2006/table">
             <a:tbl>
               <a:tblPr/>
               <a:tblGrid>
-                <a:gridCol w="2025534"/>
-                <a:gridCol w="1072342"/>
-                <a:gridCol w="953193"/>
-                <a:gridCol w="953193"/>
-                <a:gridCol w="953193"/>
+                <a:gridCol w="2025534">
+                  <a:extLst>
+                    <a:ext uri="{9D8B030D-6E8A-4147-A177-3AD203B41FA5}">
+                      <a16:colId xmlns:a16="http://schemas.microsoft.com/office/drawing/2014/main" val="20000"/>
+                    </a:ext>
+                  </a:extLst>
+                </a:gridCol>
+                <a:gridCol w="1072342">
+                  <a:extLst>
+                    <a:ext uri="{9D8B030D-6E8A-4147-A177-3AD203B41FA5}">
+                      <a16:colId xmlns:a16="http://schemas.microsoft.com/office/drawing/2014/main" val="20001"/>
+                    </a:ext>
+                  </a:extLst>
+                </a:gridCol>
+                <a:gridCol w="953193">
+                  <a:extLst>
+                    <a:ext uri="{9D8B030D-6E8A-4147-A177-3AD203B41FA5}">
+                      <a16:colId xmlns:a16="http://schemas.microsoft.com/office/drawing/2014/main" val="20002"/>
+                    </a:ext>
+                  </a:extLst>
+                </a:gridCol>
+                <a:gridCol w="953193">
+                  <a:extLst>
+                    <a:ext uri="{9D8B030D-6E8A-4147-A177-3AD203B41FA5}">
+                      <a16:colId xmlns:a16="http://schemas.microsoft.com/office/drawing/2014/main" val="20003"/>
+                    </a:ext>
+                  </a:extLst>
+                </a:gridCol>
+                <a:gridCol w="953193">
+                  <a:extLst>
+                    <a:ext uri="{9D8B030D-6E8A-4147-A177-3AD203B41FA5}">
+                      <a16:colId xmlns:a16="http://schemas.microsoft.com/office/drawing/2014/main" val="20004"/>
+                    </a:ext>
+                  </a:extLst>
+                </a:gridCol>
               </a:tblGrid>
               <a:tr h="633647">
                 <a:tc>
@@ -3096,7 +2913,7 @@
                     <a:bodyPr/>
                     <a:lstStyle/>
                     <a:p>
-                      <a:pPr indent="0" marL="0">
+                      <a:pPr marL="0" indent="0">
                         <a:lnSpc>
                           <a:spcPts val="1960"/>
                         </a:lnSpc>
@@ -3120,7 +2937,7 @@
                       </a:endParaRPr>
                     </a:p>
                   </a:txBody>
-                  <a:tcPr marL="62230" marR="62230" marT="62230" marB="62230" anchor="t">
+                  <a:tcPr marL="62230" marR="62230" marT="62230" marB="62230">
                     <a:lnL w="12700" cap="flat" cmpd="sng" algn="ctr">
                       <a:solidFill>
                         <a:srgbClr val="C4C3BE"/>
@@ -3167,7 +2984,7 @@
                     <a:bodyPr/>
                     <a:lstStyle/>
                     <a:p>
-                      <a:pPr algn="r" indent="0" marL="0">
+                      <a:pPr marL="0" indent="0" algn="r">
                         <a:lnSpc>
                           <a:spcPts val="1960"/>
                         </a:lnSpc>
@@ -3191,7 +3008,7 @@
                       </a:endParaRPr>
                     </a:p>
                   </a:txBody>
-                  <a:tcPr marL="62230" marR="62230" marT="62230" marB="62230" anchor="t">
+                  <a:tcPr marL="62230" marR="62230" marT="62230" marB="62230">
                     <a:lnL w="12700" cap="flat" cmpd="sng" algn="ctr">
                       <a:solidFill>
                         <a:srgbClr val="141E34"/>
@@ -3238,7 +3055,7 @@
                     <a:bodyPr/>
                     <a:lstStyle/>
                     <a:p>
-                      <a:pPr algn="r" indent="0" marL="0">
+                      <a:pPr marL="0" indent="0" algn="r">
                         <a:lnSpc>
                           <a:spcPts val="1960"/>
                         </a:lnSpc>
@@ -3262,7 +3079,7 @@
                       </a:endParaRPr>
                     </a:p>
                   </a:txBody>
-                  <a:tcPr marL="62230" marR="62230" marT="62230" marB="62230" anchor="t">
+                  <a:tcPr marL="62230" marR="62230" marT="62230" marB="62230">
                     <a:lnL w="12700" cap="flat" cmpd="sng" algn="ctr">
                       <a:solidFill>
                         <a:srgbClr val="141E34"/>
@@ -3309,7 +3126,7 @@
                     <a:bodyPr/>
                     <a:lstStyle/>
                     <a:p>
-                      <a:pPr algn="r" indent="0" marL="0">
+                      <a:pPr marL="0" indent="0" algn="r">
                         <a:lnSpc>
                           <a:spcPts val="1960"/>
                         </a:lnSpc>
@@ -3333,7 +3150,7 @@
                       </a:endParaRPr>
                     </a:p>
                   </a:txBody>
-                  <a:tcPr marL="62230" marR="62230" marT="62230" marB="62230" anchor="t">
+                  <a:tcPr marL="62230" marR="62230" marT="62230" marB="62230">
                     <a:lnL w="12700" cap="flat" cmpd="sng" algn="ctr">
                       <a:solidFill>
                         <a:srgbClr val="141E34"/>
@@ -3380,7 +3197,7 @@
                     <a:bodyPr/>
                     <a:lstStyle/>
                     <a:p>
-                      <a:pPr algn="r" indent="0" marL="0">
+                      <a:pPr marL="0" indent="0" algn="r">
                         <a:lnSpc>
                           <a:spcPts val="1960"/>
                         </a:lnSpc>
@@ -3404,7 +3221,7 @@
                       </a:endParaRPr>
                     </a:p>
                   </a:txBody>
-                  <a:tcPr marL="62230" marR="62230" marT="62230" marB="62230" anchor="t">
+                  <a:tcPr marL="62230" marR="62230" marT="62230" marB="62230">
                     <a:lnL w="12700" cap="flat" cmpd="sng" algn="ctr">
                       <a:solidFill>
                         <a:srgbClr val="141E34"/>
@@ -3446,6 +3263,11 @@
                     </a:solidFill>
                   </a:tcPr>
                 </a:tc>
+                <a:extLst>
+                  <a:ext uri="{0D108BD9-81ED-4DB2-BD59-A6C34878D82A}">
+                    <a16:rowId xmlns:a16="http://schemas.microsoft.com/office/drawing/2014/main" val="10000"/>
+                  </a:ext>
+                </a:extLst>
               </a:tr>
               <a:tr h="384788">
                 <a:tc>
@@ -3453,7 +3275,7 @@
                     <a:bodyPr/>
                     <a:lstStyle/>
                     <a:p>
-                      <a:pPr indent="0" marL="0">
+                      <a:pPr marL="0" indent="0">
                         <a:lnSpc>
                           <a:spcPts val="1960"/>
                         </a:lnSpc>
@@ -3477,7 +3299,7 @@
                       </a:endParaRPr>
                     </a:p>
                   </a:txBody>
-                  <a:tcPr marL="62230" marR="62230" marT="62230" marB="62230" anchor="t">
+                  <a:tcPr marL="62230" marR="62230" marT="62230" marB="62230">
                     <a:lnL w="12700" cap="flat" cmpd="sng" algn="ctr">
                       <a:solidFill>
                         <a:srgbClr val="C4C3BE"/>
@@ -3521,7 +3343,7 @@
                     <a:bodyPr/>
                     <a:lstStyle/>
                     <a:p>
-                      <a:pPr algn="r" indent="0" marL="0">
+                      <a:pPr marL="0" indent="0" algn="r">
                         <a:lnSpc>
                           <a:spcPts val="1960"/>
                         </a:lnSpc>
@@ -3545,7 +3367,7 @@
                       </a:endParaRPr>
                     </a:p>
                   </a:txBody>
-                  <a:tcPr marL="62230" marR="62230" marT="62230" marB="62230" anchor="t">
+                  <a:tcPr marL="62230" marR="62230" marT="62230" marB="62230">
                     <a:lnL w="12700" cap="flat" cmpd="sng" algn="ctr">
                       <a:solidFill>
                         <a:srgbClr val="C4C3BE"/>
@@ -3589,7 +3411,7 @@
                     <a:bodyPr/>
                     <a:lstStyle/>
                     <a:p>
-                      <a:pPr algn="r" indent="0" marL="0">
+                      <a:pPr marL="0" indent="0" algn="r">
                         <a:lnSpc>
                           <a:spcPts val="1960"/>
                         </a:lnSpc>
@@ -3613,7 +3435,7 @@
                       </a:endParaRPr>
                     </a:p>
                   </a:txBody>
-                  <a:tcPr marL="62230" marR="62230" marT="62230" marB="62230" anchor="t">
+                  <a:tcPr marL="62230" marR="62230" marT="62230" marB="62230">
                     <a:lnL w="12700" cap="flat" cmpd="sng" algn="ctr">
                       <a:solidFill>
                         <a:srgbClr val="C4C3BE"/>
@@ -3657,7 +3479,7 @@
                     <a:bodyPr/>
                     <a:lstStyle/>
                     <a:p>
-                      <a:pPr algn="r" indent="0" marL="0">
+                      <a:pPr marL="0" indent="0" algn="r">
                         <a:lnSpc>
                           <a:spcPts val="1960"/>
                         </a:lnSpc>
@@ -3681,7 +3503,7 @@
                       </a:endParaRPr>
                     </a:p>
                   </a:txBody>
-                  <a:tcPr marL="62230" marR="62230" marT="62230" marB="62230" anchor="t">
+                  <a:tcPr marL="62230" marR="62230" marT="62230" marB="62230">
                     <a:lnL w="12700" cap="flat" cmpd="sng" algn="ctr">
                       <a:solidFill>
                         <a:srgbClr val="C4C3BE"/>
@@ -3725,7 +3547,7 @@
                     <a:bodyPr/>
                     <a:lstStyle/>
                     <a:p>
-                      <a:pPr algn="r" indent="0" marL="0">
+                      <a:pPr marL="0" indent="0" algn="r">
                         <a:lnSpc>
                           <a:spcPts val="1960"/>
                         </a:lnSpc>
@@ -3749,7 +3571,7 @@
                       </a:endParaRPr>
                     </a:p>
                   </a:txBody>
-                  <a:tcPr marL="62230" marR="62230" marT="62230" marB="62230" anchor="t">
+                  <a:tcPr marL="62230" marR="62230" marT="62230" marB="62230">
                     <a:lnL w="12700" cap="flat" cmpd="sng" algn="ctr">
                       <a:solidFill>
                         <a:srgbClr val="C4C3BE"/>
@@ -3788,6 +3610,11 @@
                     </a:lnB>
                   </a:tcPr>
                 </a:tc>
+                <a:extLst>
+                  <a:ext uri="{0D108BD9-81ED-4DB2-BD59-A6C34878D82A}">
+                    <a16:rowId xmlns:a16="http://schemas.microsoft.com/office/drawing/2014/main" val="10001"/>
+                  </a:ext>
+                </a:extLst>
               </a:tr>
               <a:tr h="384788">
                 <a:tc>
@@ -3795,7 +3622,7 @@
                     <a:bodyPr/>
                     <a:lstStyle/>
                     <a:p>
-                      <a:pPr indent="0" marL="0">
+                      <a:pPr marL="0" indent="0">
                         <a:lnSpc>
                           <a:spcPts val="1960"/>
                         </a:lnSpc>
@@ -3819,7 +3646,7 @@
                       </a:endParaRPr>
                     </a:p>
                   </a:txBody>
-                  <a:tcPr marL="62230" marR="62230" marT="62230" marB="62230" anchor="t">
+                  <a:tcPr marL="62230" marR="62230" marT="62230" marB="62230">
                     <a:lnL w="12700" cap="flat" cmpd="sng" algn="ctr">
                       <a:solidFill>
                         <a:srgbClr val="C4C3BE"/>
@@ -3863,7 +3690,7 @@
                     <a:bodyPr/>
                     <a:lstStyle/>
                     <a:p>
-                      <a:pPr algn="r" indent="0" marL="0">
+                      <a:pPr marL="0" indent="0" algn="r">
                         <a:lnSpc>
                           <a:spcPts val="1960"/>
                         </a:lnSpc>
@@ -3887,7 +3714,7 @@
                       </a:endParaRPr>
                     </a:p>
                   </a:txBody>
-                  <a:tcPr marL="62230" marR="62230" marT="62230" marB="62230" anchor="t">
+                  <a:tcPr marL="62230" marR="62230" marT="62230" marB="62230">
                     <a:lnL w="12700" cap="flat" cmpd="sng" algn="ctr">
                       <a:solidFill>
                         <a:srgbClr val="C4C3BE"/>
@@ -3931,7 +3758,7 @@
                     <a:bodyPr/>
                     <a:lstStyle/>
                     <a:p>
-                      <a:pPr algn="r" indent="0" marL="0">
+                      <a:pPr marL="0" indent="0" algn="r">
                         <a:lnSpc>
                           <a:spcPts val="1960"/>
                         </a:lnSpc>
@@ -3955,7 +3782,7 @@
                       </a:endParaRPr>
                     </a:p>
                   </a:txBody>
-                  <a:tcPr marL="62230" marR="62230" marT="62230" marB="62230" anchor="t">
+                  <a:tcPr marL="62230" marR="62230" marT="62230" marB="62230">
                     <a:lnL w="12700" cap="flat" cmpd="sng" algn="ctr">
                       <a:solidFill>
                         <a:srgbClr val="C4C3BE"/>
@@ -3999,7 +3826,7 @@
                     <a:bodyPr/>
                     <a:lstStyle/>
                     <a:p>
-                      <a:pPr algn="r" indent="0" marL="0">
+                      <a:pPr marL="0" indent="0" algn="r">
                         <a:lnSpc>
                           <a:spcPts val="1960"/>
                         </a:lnSpc>
@@ -4023,7 +3850,7 @@
                       </a:endParaRPr>
                     </a:p>
                   </a:txBody>
-                  <a:tcPr marL="62230" marR="62230" marT="62230" marB="62230" anchor="t">
+                  <a:tcPr marL="62230" marR="62230" marT="62230" marB="62230">
                     <a:lnL w="12700" cap="flat" cmpd="sng" algn="ctr">
                       <a:solidFill>
                         <a:srgbClr val="C4C3BE"/>
@@ -4067,7 +3894,7 @@
                     <a:bodyPr/>
                     <a:lstStyle/>
                     <a:p>
-                      <a:pPr algn="r" indent="0" marL="0">
+                      <a:pPr marL="0" indent="0" algn="r">
                         <a:lnSpc>
                           <a:spcPts val="1960"/>
                         </a:lnSpc>
@@ -4091,7 +3918,7 @@
                       </a:endParaRPr>
                     </a:p>
                   </a:txBody>
-                  <a:tcPr marL="62230" marR="62230" marT="62230" marB="62230" anchor="t">
+                  <a:tcPr marL="62230" marR="62230" marT="62230" marB="62230">
                     <a:lnL w="12700" cap="flat" cmpd="sng" algn="ctr">
                       <a:solidFill>
                         <a:srgbClr val="C4C3BE"/>
@@ -4130,6 +3957,11 @@
                     </a:lnB>
                   </a:tcPr>
                 </a:tc>
+                <a:extLst>
+                  <a:ext uri="{0D108BD9-81ED-4DB2-BD59-A6C34878D82A}">
+                    <a16:rowId xmlns:a16="http://schemas.microsoft.com/office/drawing/2014/main" val="10002"/>
+                  </a:ext>
+                </a:extLst>
               </a:tr>
               <a:tr h="384788">
                 <a:tc>
@@ -4137,7 +3969,7 @@
                     <a:bodyPr/>
                     <a:lstStyle/>
                     <a:p>
-                      <a:pPr indent="0" marL="0">
+                      <a:pPr marL="0" indent="0">
                         <a:lnSpc>
                           <a:spcPts val="1960"/>
                         </a:lnSpc>
@@ -4161,7 +3993,7 @@
                       </a:endParaRPr>
                     </a:p>
                   </a:txBody>
-                  <a:tcPr marL="62230" marR="62230" marT="62230" marB="62230" anchor="t">
+                  <a:tcPr marL="62230" marR="62230" marT="62230" marB="62230">
                     <a:lnL w="12700" cap="flat" cmpd="sng" algn="ctr">
                       <a:solidFill>
                         <a:srgbClr val="C4C3BE"/>
@@ -4208,7 +4040,7 @@
                     <a:bodyPr/>
                     <a:lstStyle/>
                     <a:p>
-                      <a:pPr algn="r" indent="0" marL="0">
+                      <a:pPr marL="0" indent="0" algn="r">
                         <a:lnSpc>
                           <a:spcPts val="1960"/>
                         </a:lnSpc>
@@ -4232,7 +4064,7 @@
                       </a:endParaRPr>
                     </a:p>
                   </a:txBody>
-                  <a:tcPr marL="62230" marR="62230" marT="62230" marB="62230" anchor="t">
+                  <a:tcPr marL="62230" marR="62230" marT="62230" marB="62230">
                     <a:lnL w="12700" cap="flat" cmpd="sng" algn="ctr">
                       <a:solidFill>
                         <a:srgbClr val="B1BCBB"/>
@@ -4279,7 +4111,7 @@
                     <a:bodyPr/>
                     <a:lstStyle/>
                     <a:p>
-                      <a:pPr algn="r" indent="0" marL="0">
+                      <a:pPr marL="0" indent="0" algn="r">
                         <a:lnSpc>
                           <a:spcPts val="1960"/>
                         </a:lnSpc>
@@ -4303,7 +4135,7 @@
                       </a:endParaRPr>
                     </a:p>
                   </a:txBody>
-                  <a:tcPr marL="62230" marR="62230" marT="62230" marB="62230" anchor="t">
+                  <a:tcPr marL="62230" marR="62230" marT="62230" marB="62230">
                     <a:lnL w="12700" cap="flat" cmpd="sng" algn="ctr">
                       <a:solidFill>
                         <a:srgbClr val="B1BCBB"/>
@@ -4350,7 +4182,7 @@
                     <a:bodyPr/>
                     <a:lstStyle/>
                     <a:p>
-                      <a:pPr algn="r" indent="0" marL="0">
+                      <a:pPr marL="0" indent="0" algn="r">
                         <a:lnSpc>
                           <a:spcPts val="1960"/>
                         </a:lnSpc>
@@ -4374,7 +4206,7 @@
                       </a:endParaRPr>
                     </a:p>
                   </a:txBody>
-                  <a:tcPr marL="62230" marR="62230" marT="62230" marB="62230" anchor="t">
+                  <a:tcPr marL="62230" marR="62230" marT="62230" marB="62230">
                     <a:lnL w="12700" cap="flat" cmpd="sng" algn="ctr">
                       <a:solidFill>
                         <a:srgbClr val="B1BCBB"/>
@@ -4421,7 +4253,7 @@
                     <a:bodyPr/>
                     <a:lstStyle/>
                     <a:p>
-                      <a:pPr algn="r" indent="0" marL="0">
+                      <a:pPr marL="0" indent="0" algn="r">
                         <a:lnSpc>
                           <a:spcPts val="1960"/>
                         </a:lnSpc>
@@ -4445,7 +4277,7 @@
                       </a:endParaRPr>
                     </a:p>
                   </a:txBody>
-                  <a:tcPr marL="62230" marR="62230" marT="62230" marB="62230" anchor="t">
+                  <a:tcPr marL="62230" marR="62230" marT="62230" marB="62230">
                     <a:lnL w="12700" cap="flat" cmpd="sng" algn="ctr">
                       <a:solidFill>
                         <a:srgbClr val="B1BCBB"/>
@@ -4487,6 +4319,11 @@
                     </a:solidFill>
                   </a:tcPr>
                 </a:tc>
+                <a:extLst>
+                  <a:ext uri="{0D108BD9-81ED-4DB2-BD59-A6C34878D82A}">
+                    <a16:rowId xmlns:a16="http://schemas.microsoft.com/office/drawing/2014/main" val="10003"/>
+                  </a:ext>
+                </a:extLst>
               </a:tr>
               <a:tr h="384788">
                 <a:tc>
@@ -4494,7 +4331,7 @@
                     <a:bodyPr/>
                     <a:lstStyle/>
                     <a:p>
-                      <a:pPr indent="0" marL="0">
+                      <a:pPr marL="0" indent="0">
                         <a:lnSpc>
                           <a:spcPts val="1960"/>
                         </a:lnSpc>
@@ -4518,7 +4355,7 @@
                       </a:endParaRPr>
                     </a:p>
                   </a:txBody>
-                  <a:tcPr marL="62230" marR="62230" marT="62230" marB="62230" anchor="t">
+                  <a:tcPr marL="62230" marR="62230" marT="62230" marB="62230">
                     <a:lnL w="12700" cap="flat" cmpd="sng" algn="ctr">
                       <a:solidFill>
                         <a:srgbClr val="C4C3BE"/>
@@ -4565,7 +4402,7 @@
                     <a:bodyPr/>
                     <a:lstStyle/>
                     <a:p>
-                      <a:pPr algn="r" indent="0" marL="0">
+                      <a:pPr marL="0" indent="0" algn="r">
                         <a:lnSpc>
                           <a:spcPts val="1960"/>
                         </a:lnSpc>
@@ -4589,7 +4426,7 @@
                       </a:endParaRPr>
                     </a:p>
                   </a:txBody>
-                  <a:tcPr marL="62230" marR="62230" marT="62230" marB="62230" anchor="t">
+                  <a:tcPr marL="62230" marR="62230" marT="62230" marB="62230">
                     <a:lnL w="12700" cap="flat" cmpd="sng" algn="ctr">
                       <a:solidFill>
                         <a:srgbClr val="B1BCBB"/>
@@ -4636,7 +4473,7 @@
                     <a:bodyPr/>
                     <a:lstStyle/>
                     <a:p>
-                      <a:pPr algn="r" indent="0" marL="0">
+                      <a:pPr marL="0" indent="0" algn="r">
                         <a:lnSpc>
                           <a:spcPts val="1960"/>
                         </a:lnSpc>
@@ -4660,7 +4497,7 @@
                       </a:endParaRPr>
                     </a:p>
                   </a:txBody>
-                  <a:tcPr marL="62230" marR="62230" marT="62230" marB="62230" anchor="t">
+                  <a:tcPr marL="62230" marR="62230" marT="62230" marB="62230">
                     <a:lnL w="12700" cap="flat" cmpd="sng" algn="ctr">
                       <a:solidFill>
                         <a:srgbClr val="B1BCBB"/>
@@ -4707,7 +4544,7 @@
                     <a:bodyPr/>
                     <a:lstStyle/>
                     <a:p>
-                      <a:pPr algn="r" indent="0" marL="0">
+                      <a:pPr marL="0" indent="0" algn="r">
                         <a:lnSpc>
                           <a:spcPts val="1960"/>
                         </a:lnSpc>
@@ -4731,7 +4568,7 @@
                       </a:endParaRPr>
                     </a:p>
                   </a:txBody>
-                  <a:tcPr marL="62230" marR="62230" marT="62230" marB="62230" anchor="t">
+                  <a:tcPr marL="62230" marR="62230" marT="62230" marB="62230">
                     <a:lnL w="12700" cap="flat" cmpd="sng" algn="ctr">
                       <a:solidFill>
                         <a:srgbClr val="B1BCBB"/>
@@ -4778,7 +4615,7 @@
                     <a:bodyPr/>
                     <a:lstStyle/>
                     <a:p>
-                      <a:pPr algn="r" indent="0" marL="0">
+                      <a:pPr marL="0" indent="0" algn="r">
                         <a:lnSpc>
                           <a:spcPts val="1960"/>
                         </a:lnSpc>
@@ -4802,7 +4639,7 @@
                       </a:endParaRPr>
                     </a:p>
                   </a:txBody>
-                  <a:tcPr marL="62230" marR="62230" marT="62230" marB="62230" anchor="t">
+                  <a:tcPr marL="62230" marR="62230" marT="62230" marB="62230">
                     <a:lnL w="12700" cap="flat" cmpd="sng" algn="ctr">
                       <a:solidFill>
                         <a:srgbClr val="B1BCBB"/>
@@ -4844,6 +4681,11 @@
                     </a:solidFill>
                   </a:tcPr>
                 </a:tc>
+                <a:extLst>
+                  <a:ext uri="{0D108BD9-81ED-4DB2-BD59-A6C34878D82A}">
+                    <a16:rowId xmlns:a16="http://schemas.microsoft.com/office/drawing/2014/main" val="10004"/>
+                  </a:ext>
+                </a:extLst>
               </a:tr>
               <a:tr h="384788">
                 <a:tc>
@@ -4851,7 +4693,7 @@
                     <a:bodyPr/>
                     <a:lstStyle/>
                     <a:p>
-                      <a:pPr indent="0" marL="0">
+                      <a:pPr marL="0" indent="0">
                         <a:lnSpc>
                           <a:spcPts val="1960"/>
                         </a:lnSpc>
@@ -4875,7 +4717,7 @@
                       </a:endParaRPr>
                     </a:p>
                   </a:txBody>
-                  <a:tcPr marL="62230" marR="62230" marT="62230" marB="62230" anchor="t">
+                  <a:tcPr marL="62230" marR="62230" marT="62230" marB="62230">
                     <a:lnL w="12700" cap="flat" cmpd="sng" algn="ctr">
                       <a:solidFill>
                         <a:srgbClr val="C4C3BE"/>
@@ -4922,7 +4764,7 @@
                     <a:bodyPr/>
                     <a:lstStyle/>
                     <a:p>
-                      <a:pPr algn="r" indent="0" marL="0">
+                      <a:pPr marL="0" indent="0" algn="r">
                         <a:lnSpc>
                           <a:spcPts val="1960"/>
                         </a:lnSpc>
@@ -4946,7 +4788,7 @@
                       </a:endParaRPr>
                     </a:p>
                   </a:txBody>
-                  <a:tcPr marL="62230" marR="62230" marT="62230" marB="62230" anchor="t">
+                  <a:tcPr marL="62230" marR="62230" marT="62230" marB="62230">
                     <a:lnL w="12700" cap="flat" cmpd="sng" algn="ctr">
                       <a:solidFill>
                         <a:srgbClr val="B1BCBB"/>
@@ -4993,7 +4835,7 @@
                     <a:bodyPr/>
                     <a:lstStyle/>
                     <a:p>
-                      <a:pPr algn="r" indent="0" marL="0">
+                      <a:pPr marL="0" indent="0" algn="r">
                         <a:lnSpc>
                           <a:spcPts val="1960"/>
                         </a:lnSpc>
@@ -5017,7 +4859,7 @@
                       </a:endParaRPr>
                     </a:p>
                   </a:txBody>
-                  <a:tcPr marL="62230" marR="62230" marT="62230" marB="62230" anchor="t">
+                  <a:tcPr marL="62230" marR="62230" marT="62230" marB="62230">
                     <a:lnL w="12700" cap="flat" cmpd="sng" algn="ctr">
                       <a:solidFill>
                         <a:srgbClr val="B1BCBB"/>
@@ -5064,7 +4906,7 @@
                     <a:bodyPr/>
                     <a:lstStyle/>
                     <a:p>
-                      <a:pPr algn="r" indent="0" marL="0">
+                      <a:pPr marL="0" indent="0" algn="r">
                         <a:lnSpc>
                           <a:spcPts val="1960"/>
                         </a:lnSpc>
@@ -5088,7 +4930,7 @@
                       </a:endParaRPr>
                     </a:p>
                   </a:txBody>
-                  <a:tcPr marL="62230" marR="62230" marT="62230" marB="62230" anchor="t">
+                  <a:tcPr marL="62230" marR="62230" marT="62230" marB="62230">
                     <a:lnL w="12700" cap="flat" cmpd="sng" algn="ctr">
                       <a:solidFill>
                         <a:srgbClr val="B1BCBB"/>
@@ -5135,7 +4977,7 @@
                     <a:bodyPr/>
                     <a:lstStyle/>
                     <a:p>
-                      <a:pPr algn="r" indent="0" marL="0">
+                      <a:pPr marL="0" indent="0" algn="r">
                         <a:lnSpc>
                           <a:spcPts val="1960"/>
                         </a:lnSpc>
@@ -5159,7 +5001,7 @@
                       </a:endParaRPr>
                     </a:p>
                   </a:txBody>
-                  <a:tcPr marL="62230" marR="62230" marT="62230" marB="62230" anchor="t">
+                  <a:tcPr marL="62230" marR="62230" marT="62230" marB="62230">
                     <a:lnL w="12700" cap="flat" cmpd="sng" algn="ctr">
                       <a:solidFill>
                         <a:srgbClr val="B1BCBB"/>
@@ -5201,6 +5043,11 @@
                     </a:solidFill>
                   </a:tcPr>
                 </a:tc>
+                <a:extLst>
+                  <a:ext uri="{0D108BD9-81ED-4DB2-BD59-A6C34878D82A}">
+                    <a16:rowId xmlns:a16="http://schemas.microsoft.com/office/drawing/2014/main" val="10005"/>
+                  </a:ext>
+                </a:extLst>
               </a:tr>
               <a:tr h="384788">
                 <a:tc>
@@ -5208,7 +5055,7 @@
                     <a:bodyPr/>
                     <a:lstStyle/>
                     <a:p>
-                      <a:pPr indent="0" marL="0">
+                      <a:pPr marL="0" indent="0">
                         <a:lnSpc>
                           <a:spcPts val="1960"/>
                         </a:lnSpc>
@@ -5232,7 +5079,7 @@
                       </a:endParaRPr>
                     </a:p>
                   </a:txBody>
-                  <a:tcPr marL="62230" marR="62230" marT="62230" marB="62230" anchor="t">
+                  <a:tcPr marL="62230" marR="62230" marT="62230" marB="62230">
                     <a:lnL w="12700" cap="flat" cmpd="sng" algn="ctr">
                       <a:solidFill>
                         <a:srgbClr val="C4C3BE"/>
@@ -5279,7 +5126,7 @@
                     <a:bodyPr/>
                     <a:lstStyle/>
                     <a:p>
-                      <a:pPr algn="r" indent="0" marL="0">
+                      <a:pPr marL="0" indent="0" algn="r">
                         <a:lnSpc>
                           <a:spcPts val="1960"/>
                         </a:lnSpc>
@@ -5303,7 +5150,7 @@
                       </a:endParaRPr>
                     </a:p>
                   </a:txBody>
-                  <a:tcPr marL="62230" marR="62230" marT="62230" marB="62230" anchor="t">
+                  <a:tcPr marL="62230" marR="62230" marT="62230" marB="62230">
                     <a:lnL w="12700" cap="flat" cmpd="sng" algn="ctr">
                       <a:solidFill>
                         <a:srgbClr val="B1BCBB"/>
@@ -5350,7 +5197,7 @@
                     <a:bodyPr/>
                     <a:lstStyle/>
                     <a:p>
-                      <a:pPr algn="r" indent="0" marL="0">
+                      <a:pPr marL="0" indent="0" algn="r">
                         <a:lnSpc>
                           <a:spcPts val="1960"/>
                         </a:lnSpc>
@@ -5374,7 +5221,7 @@
                       </a:endParaRPr>
                     </a:p>
                   </a:txBody>
-                  <a:tcPr marL="62230" marR="62230" marT="62230" marB="62230" anchor="t">
+                  <a:tcPr marL="62230" marR="62230" marT="62230" marB="62230">
                     <a:lnL w="12700" cap="flat" cmpd="sng" algn="ctr">
                       <a:solidFill>
                         <a:srgbClr val="B1BCBB"/>
@@ -5421,7 +5268,7 @@
                     <a:bodyPr/>
                     <a:lstStyle/>
                     <a:p>
-                      <a:pPr algn="r" indent="0" marL="0">
+                      <a:pPr marL="0" indent="0" algn="r">
                         <a:lnSpc>
                           <a:spcPts val="1960"/>
                         </a:lnSpc>
@@ -5445,7 +5292,7 @@
                       </a:endParaRPr>
                     </a:p>
                   </a:txBody>
-                  <a:tcPr marL="62230" marR="62230" marT="62230" marB="62230" anchor="t">
+                  <a:tcPr marL="62230" marR="62230" marT="62230" marB="62230">
                     <a:lnL w="12700" cap="flat" cmpd="sng" algn="ctr">
                       <a:solidFill>
                         <a:srgbClr val="B1BCBB"/>
@@ -5492,7 +5339,7 @@
                     <a:bodyPr/>
                     <a:lstStyle/>
                     <a:p>
-                      <a:pPr algn="r" indent="0" marL="0">
+                      <a:pPr marL="0" indent="0" algn="r">
                         <a:lnSpc>
                           <a:spcPts val="1960"/>
                         </a:lnSpc>
@@ -5516,7 +5363,7 @@
                       </a:endParaRPr>
                     </a:p>
                   </a:txBody>
-                  <a:tcPr marL="62230" marR="62230" marT="62230" marB="62230" anchor="t">
+                  <a:tcPr marL="62230" marR="62230" marT="62230" marB="62230">
                     <a:lnL w="12700" cap="flat" cmpd="sng" algn="ctr">
                       <a:solidFill>
                         <a:srgbClr val="B1BCBB"/>
@@ -5558,6 +5405,11 @@
                     </a:solidFill>
                   </a:tcPr>
                 </a:tc>
+                <a:extLst>
+                  <a:ext uri="{0D108BD9-81ED-4DB2-BD59-A6C34878D82A}">
+                    <a16:rowId xmlns:a16="http://schemas.microsoft.com/office/drawing/2014/main" val="10006"/>
+                  </a:ext>
+                </a:extLst>
               </a:tr>
             </a:tbl>
           </a:graphicData>
@@ -5587,15 +5439,15 @@
       </p:sp>
       <p:pic>
         <p:nvPicPr>
-          <p:cNvPr id="6" name="Image 0" descr="Validation MSE against epoch for the direct network and the three PCA networks over 1,000 epochs; the direct curve levels off near 0.35 while the PCA curves are still slowly falling">    </p:cNvPr>
+          <p:cNvPr id="6" name="Image 0" descr="Validation MSE against epoch for the direct network and the three PCA networks over 1,000 epochs; the direct curve levels off near 0.35 while the PCA curves are still slowly falling"/>
           <p:cNvPicPr>
             <a:picLocks noChangeAspect="1"/>
           </p:cNvPicPr>
           <p:nvPr/>
         </p:nvPicPr>
         <p:blipFill>
-          <a:blip r:embed="rId1"/>
-          <a:srcRect l="-40" r="-40" t="0" b="0"/>
+          <a:blip r:embed="rId3"/>
+          <a:srcRect l="-40" r="-40"/>
           <a:stretch/>
         </p:blipFill>
         <p:spPr>
@@ -5658,7 +5510,7 @@
           </a:bodyPr>
           <a:lstStyle/>
           <a:p>
-            <a:pPr algn="l" indent="0" marL="0">
+            <a:pPr marL="0" indent="0" algn="l">
               <a:lnSpc>
                 <a:spcPts val="1680"/>
               </a:lnSpc>
@@ -5702,7 +5554,7 @@
           </a:bodyPr>
           <a:lstStyle/>
           <a:p>
-            <a:pPr algn="l" indent="0" marL="0">
+            <a:pPr marL="0" indent="0" algn="l">
               <a:lnSpc>
                 <a:spcPts val="2100"/>
               </a:lnSpc>
@@ -5746,7 +5598,7 @@
           </a:bodyPr>
           <a:lstStyle/>
           <a:p>
-            <a:pPr algn="l" indent="0" marL="0">
+            <a:pPr marL="0" indent="0" algn="l">
               <a:lnSpc>
                 <a:spcPts val="1680"/>
               </a:lnSpc>
@@ -5790,7 +5642,7 @@
           </a:bodyPr>
           <a:lstStyle/>
           <a:p>
-            <a:pPr algn="r" indent="0" marL="0">
+            <a:pPr marL="0" indent="0" algn="r">
               <a:lnSpc>
                 <a:spcPts val="1680"/>
               </a:lnSpc>
@@ -5827,6 +5679,7 @@
         <a:solidFill>
           <a:srgbClr val="F6F4EE"/>
         </a:solidFill>
+        <a:effectLst/>
       </p:bgPr>
     </p:bg>
     <p:spTree>
@@ -5866,14 +5719,14 @@
           </a:bodyPr>
           <a:lstStyle/>
           <a:p>
-            <a:pPr algn="l" indent="0" marL="0">
+            <a:pPr marL="0" indent="0" algn="l">
               <a:lnSpc>
                 <a:spcPts val="1680"/>
               </a:lnSpc>
               <a:buNone/>
             </a:pPr>
             <a:r>
-              <a:rPr lang="en-US" sz="1200" b="1" spc="100" kern="0" dirty="0">
+              <a:rPr lang="en-US" sz="1200" b="1" kern="0" spc="100" dirty="0">
                 <a:solidFill>
                   <a:srgbClr val="17757A"/>
                 </a:solidFill>
@@ -5890,7 +5743,9 @@
       <p:sp>
         <p:nvSpPr>
           <p:cNvPr id="3" name="Text 1"/>
-          <p:cNvSpPr/>
+          <p:cNvSpPr>
+            <a:spLocks noGrp="1"/>
+          </p:cNvSpPr>
           <p:nvPr>
             <p:ph type="title"/>
           </p:nvPr>
@@ -5912,7 +5767,7 @@
           </a:bodyPr>
           <a:lstStyle/>
           <a:p>
-            <a:pPr algn="l" indent="0" marL="0">
+            <a:pPr marL="0" indent="0" algn="l">
               <a:lnSpc>
                 <a:spcPts val="3080"/>
               </a:lnSpc>
@@ -5957,15 +5812,15 @@
       </p:sp>
       <p:pic>
         <p:nvPicPr>
-          <p:cNvPr id="5" name="Image 0" descr="Left: cumulative explained variance against number of principal components, rising steeply and passing 95 percent by about 60 components. Right: reconstruction error of a perfect predictor falling from about 1.2 at one component to about 0.03 at 256">    </p:cNvPr>
+          <p:cNvPr id="5" name="Image 0" descr="Left: cumulative explained variance against number of principal components, rising steeply and passing 95 percent by about 60 components. Right: reconstruction error of a perfect predictor falling from about 1.2 at one component to about 0.03 at 256"/>
           <p:cNvPicPr>
             <a:picLocks noChangeAspect="1"/>
           </p:cNvPicPr>
           <p:nvPr/>
         </p:nvPicPr>
         <p:blipFill>
-          <a:blip r:embed="rId1"/>
-          <a:srcRect l="-164" r="-164" t="0" b="0"/>
+          <a:blip r:embed="rId3"/>
+          <a:srcRect l="-164" r="-164"/>
           <a:stretch/>
         </p:blipFill>
         <p:spPr>
@@ -6050,7 +5905,7 @@
           </a:bodyPr>
           <a:lstStyle/>
           <a:p>
-            <a:pPr algn="l" indent="0" marL="0">
+            <a:pPr marL="0" indent="0" algn="l">
               <a:lnSpc>
                 <a:spcPts val="3080"/>
               </a:lnSpc>
@@ -6094,7 +5949,7 @@
           </a:bodyPr>
           <a:lstStyle/>
           <a:p>
-            <a:pPr algn="l" indent="0" marL="0">
+            <a:pPr marL="0" indent="0" algn="l">
               <a:lnSpc>
                 <a:spcPts val="2100"/>
               </a:lnSpc>
@@ -6160,7 +6015,7 @@
           </a:bodyPr>
           <a:lstStyle/>
           <a:p>
-            <a:pPr algn="l" indent="0" marL="0">
+            <a:pPr marL="0" indent="0" algn="l">
               <a:lnSpc>
                 <a:spcPts val="3080"/>
               </a:lnSpc>
@@ -6204,7 +6059,7 @@
           </a:bodyPr>
           <a:lstStyle/>
           <a:p>
-            <a:pPr algn="l" indent="0" marL="0">
+            <a:pPr marL="0" indent="0" algn="l">
               <a:lnSpc>
                 <a:spcPts val="2100"/>
               </a:lnSpc>
@@ -6248,7 +6103,7 @@
           </a:bodyPr>
           <a:lstStyle/>
           <a:p>
-            <a:pPr algn="l" indent="0" marL="0">
+            <a:pPr marL="0" indent="0" algn="l">
               <a:lnSpc>
                 <a:spcPts val="2100"/>
               </a:lnSpc>
@@ -6292,7 +6147,7 @@
           </a:bodyPr>
           <a:lstStyle/>
           <a:p>
-            <a:pPr algn="l" indent="0" marL="0">
+            <a:pPr marL="0" indent="0" algn="l">
               <a:lnSpc>
                 <a:spcPts val="1680"/>
               </a:lnSpc>
@@ -6336,7 +6191,7 @@
           </a:bodyPr>
           <a:lstStyle/>
           <a:p>
-            <a:pPr algn="r" indent="0" marL="0">
+            <a:pPr marL="0" indent="0" algn="r">
               <a:lnSpc>
                 <a:spcPts val="1680"/>
               </a:lnSpc>
@@ -6373,6 +6228,7 @@
         <a:solidFill>
           <a:srgbClr val="F6F4EE"/>
         </a:solidFill>
+        <a:effectLst/>
       </p:bgPr>
     </p:bg>
     <p:spTree>
@@ -6412,14 +6268,14 @@
           </a:bodyPr>
           <a:lstStyle/>
           <a:p>
-            <a:pPr algn="l" indent="0" marL="0">
+            <a:pPr marL="0" indent="0" algn="l">
               <a:lnSpc>
                 <a:spcPts val="1680"/>
               </a:lnSpc>
               <a:buNone/>
             </a:pPr>
             <a:r>
-              <a:rPr lang="en-US" sz="1200" b="1" spc="100" kern="0" dirty="0">
+              <a:rPr lang="en-US" sz="1200" b="1" kern="0" spc="100" dirty="0">
                 <a:solidFill>
                   <a:srgbClr val="17757A"/>
                 </a:solidFill>
@@ -6436,7 +6292,9 @@
       <p:sp>
         <p:nvSpPr>
           <p:cNvPr id="3" name="Text 1"/>
-          <p:cNvSpPr/>
+          <p:cNvSpPr>
+            <a:spLocks noGrp="1"/>
+          </p:cNvSpPr>
           <p:nvPr>
             <p:ph type="title"/>
           </p:nvPr>
@@ -6458,7 +6316,7 @@
           </a:bodyPr>
           <a:lstStyle/>
           <a:p>
-            <a:pPr algn="l" indent="0" marL="0">
+            <a:pPr marL="0" indent="0" algn="l">
               <a:lnSpc>
                 <a:spcPts val="3080"/>
               </a:lnSpc>
@@ -6529,7 +6387,7 @@
           </a:bodyPr>
           <a:lstStyle/>
           <a:p>
-            <a:pPr algn="l" indent="0" marL="0">
+            <a:pPr marL="0" indent="0" algn="l">
               <a:lnSpc>
                 <a:spcPts val="2160"/>
               </a:lnSpc>
@@ -6573,7 +6431,7 @@
           </a:bodyPr>
           <a:lstStyle/>
           <a:p>
-            <a:pPr algn="l" marL="182880" indent="-182880">
+            <a:pPr marL="182880" indent="-182880" algn="l">
               <a:lnSpc>
                 <a:spcPts val="2250"/>
               </a:lnSpc>
@@ -6594,7 +6452,7 @@
             <a:endParaRPr lang="en-US" sz="1500" dirty="0"/>
           </a:p>
           <a:p>
-            <a:pPr algn="l" marL="182880" indent="-182880">
+            <a:pPr marL="182880" indent="-182880" algn="l">
               <a:lnSpc>
                 <a:spcPts val="2250"/>
               </a:lnSpc>
@@ -6615,7 +6473,7 @@
             <a:endParaRPr lang="en-US" sz="1500" dirty="0"/>
           </a:p>
           <a:p>
-            <a:pPr algn="l" marL="182880" indent="-182880">
+            <a:pPr marL="182880" indent="-182880" algn="l">
               <a:lnSpc>
                 <a:spcPts val="2250"/>
               </a:lnSpc>
@@ -6687,7 +6545,7 @@
           </a:bodyPr>
           <a:lstStyle/>
           <a:p>
-            <a:pPr algn="l" indent="0" marL="0">
+            <a:pPr marL="0" indent="0" algn="l">
               <a:lnSpc>
                 <a:spcPts val="2160"/>
               </a:lnSpc>
@@ -6731,7 +6589,7 @@
           </a:bodyPr>
           <a:lstStyle/>
           <a:p>
-            <a:pPr algn="l" marL="182880" indent="-182880">
+            <a:pPr marL="182880" indent="-182880" algn="l">
               <a:lnSpc>
                 <a:spcPts val="2250"/>
               </a:lnSpc>
@@ -6752,7 +6610,7 @@
             <a:endParaRPr lang="en-US" sz="1500" dirty="0"/>
           </a:p>
           <a:p>
-            <a:pPr algn="l" marL="182880" indent="-182880">
+            <a:pPr marL="182880" indent="-182880" algn="l">
               <a:lnSpc>
                 <a:spcPts val="2250"/>
               </a:lnSpc>
@@ -6773,7 +6631,7 @@
             <a:endParaRPr lang="en-US" sz="1500" dirty="0"/>
           </a:p>
           <a:p>
-            <a:pPr algn="l" marL="182880" indent="-182880">
+            <a:pPr marL="182880" indent="-182880" algn="l">
               <a:lnSpc>
                 <a:spcPts val="2250"/>
               </a:lnSpc>
@@ -6822,7 +6680,7 @@
           </a:bodyPr>
           <a:lstStyle/>
           <a:p>
-            <a:pPr algn="l" indent="0" marL="0">
+            <a:pPr marL="0" indent="0" algn="l">
               <a:lnSpc>
                 <a:spcPts val="2100"/>
               </a:lnSpc>
@@ -6866,7 +6724,7 @@
           </a:bodyPr>
           <a:lstStyle/>
           <a:p>
-            <a:pPr algn="l" indent="0" marL="0">
+            <a:pPr marL="0" indent="0" algn="l">
               <a:lnSpc>
                 <a:spcPts val="1680"/>
               </a:lnSpc>
@@ -6881,7 +6739,7 @@
                 <a:ea typeface="IBM Plex Sans" pitchFamily="34" charset="-122"/>
                 <a:cs typeface="IBM Plex Sans" pitchFamily="34" charset="-120"/>
               </a:rPr>
-              <a:t>Tejas Ponnappa (PES1UG24CS498) · Mukesh Sheregar (PES1UG24CS828)</a:t>
+              <a:t>Tejas Ponnappa (PES1UG24CS498) · Mukesh Sheregar (PES1UG25CS828)</a:t>
             </a:r>
             <a:endParaRPr lang="en-US" sz="1200" dirty="0"/>
           </a:p>
@@ -6910,7 +6768,7 @@
           </a:bodyPr>
           <a:lstStyle/>
           <a:p>
-            <a:pPr algn="r" indent="0" marL="0">
+            <a:pPr marL="0" indent="0" algn="r">
               <a:lnSpc>
                 <a:spcPts val="1680"/>
               </a:lnSpc>
@@ -6947,6 +6805,7 @@
         <a:solidFill>
           <a:srgbClr val="F6F4EE"/>
         </a:solidFill>
+        <a:effectLst/>
       </p:bgPr>
     </p:bg>
     <p:spTree>
@@ -6986,14 +6845,14 @@
           </a:bodyPr>
           <a:lstStyle/>
           <a:p>
-            <a:pPr algn="l" indent="0" marL="0">
+            <a:pPr marL="0" indent="0" algn="l">
               <a:lnSpc>
                 <a:spcPts val="1680"/>
               </a:lnSpc>
               <a:buNone/>
             </a:pPr>
             <a:r>
-              <a:rPr lang="en-US" sz="1200" b="1" spc="100" kern="0" dirty="0">
+              <a:rPr lang="en-US" sz="1200" b="1" kern="0" spc="100" dirty="0">
                 <a:solidFill>
                   <a:srgbClr val="17757A"/>
                 </a:solidFill>
@@ -7010,7 +6869,9 @@
       <p:sp>
         <p:nvSpPr>
           <p:cNvPr id="3" name="Text 1"/>
-          <p:cNvSpPr/>
+          <p:cNvSpPr>
+            <a:spLocks noGrp="1"/>
+          </p:cNvSpPr>
           <p:nvPr>
             <p:ph type="title"/>
           </p:nvPr>
@@ -7032,7 +6893,7 @@
           </a:bodyPr>
           <a:lstStyle/>
           <a:p>
-            <a:pPr algn="l" indent="0" marL="0">
+            <a:pPr marL="0" indent="0" algn="l">
               <a:lnSpc>
                 <a:spcPts val="3080"/>
               </a:lnSpc>
@@ -7076,7 +6937,7 @@
           </a:bodyPr>
           <a:lstStyle/>
           <a:p>
-            <a:pPr algn="l" indent="0" marL="0">
+            <a:pPr marL="0" indent="0" algn="l">
               <a:lnSpc>
                 <a:spcPts val="2100"/>
               </a:lnSpc>
@@ -7147,7 +7008,7 @@
           </a:bodyPr>
           <a:lstStyle/>
           <a:p>
-            <a:pPr algn="l" indent="0" marL="0">
+            <a:pPr marL="0" indent="0" algn="l">
               <a:lnSpc>
                 <a:spcPts val="2160"/>
               </a:lnSpc>
@@ -7191,7 +7052,7 @@
           </a:bodyPr>
           <a:lstStyle/>
           <a:p>
-            <a:pPr algn="l" indent="0" marL="0">
+            <a:pPr marL="0" indent="0" algn="l">
               <a:lnSpc>
                 <a:spcPts val="2100"/>
               </a:lnSpc>
@@ -7262,7 +7123,7 @@
           </a:bodyPr>
           <a:lstStyle/>
           <a:p>
-            <a:pPr algn="l" indent="0" marL="0">
+            <a:pPr marL="0" indent="0" algn="l">
               <a:lnSpc>
                 <a:spcPts val="2160"/>
               </a:lnSpc>
@@ -7306,7 +7167,7 @@
           </a:bodyPr>
           <a:lstStyle/>
           <a:p>
-            <a:pPr algn="l" indent="0" marL="0">
+            <a:pPr marL="0" indent="0" algn="l">
               <a:lnSpc>
                 <a:spcPts val="2100"/>
               </a:lnSpc>
@@ -7372,7 +7233,7 @@
           </a:bodyPr>
           <a:lstStyle/>
           <a:p>
-            <a:pPr algn="l" indent="0" marL="0">
+            <a:pPr marL="0" indent="0" algn="l">
               <a:lnSpc>
                 <a:spcPts val="2160"/>
               </a:lnSpc>
@@ -7416,7 +7277,7 @@
           </a:bodyPr>
           <a:lstStyle/>
           <a:p>
-            <a:pPr algn="l" indent="0" marL="0">
+            <a:pPr marL="0" indent="0" algn="l">
               <a:lnSpc>
                 <a:spcPts val="2100"/>
               </a:lnSpc>
@@ -7460,7 +7321,7 @@
           </a:bodyPr>
           <a:lstStyle/>
           <a:p>
-            <a:pPr algn="l" indent="0" marL="0">
+            <a:pPr marL="0" indent="0" algn="l">
               <a:lnSpc>
                 <a:spcPts val="1680"/>
               </a:lnSpc>
@@ -7504,7 +7365,7 @@
           </a:bodyPr>
           <a:lstStyle/>
           <a:p>
-            <a:pPr algn="r" indent="0" marL="0">
+            <a:pPr marL="0" indent="0" algn="r">
               <a:lnSpc>
                 <a:spcPts val="1680"/>
               </a:lnSpc>
@@ -7541,6 +7402,7 @@
         <a:solidFill>
           <a:srgbClr val="F6F4EE"/>
         </a:solidFill>
+        <a:effectLst/>
       </p:bgPr>
     </p:bg>
     <p:spTree>
@@ -7580,14 +7442,14 @@
           </a:bodyPr>
           <a:lstStyle/>
           <a:p>
-            <a:pPr algn="l" indent="0" marL="0">
+            <a:pPr marL="0" indent="0" algn="l">
               <a:lnSpc>
                 <a:spcPts val="1680"/>
               </a:lnSpc>
               <a:buNone/>
             </a:pPr>
             <a:r>
-              <a:rPr lang="en-US" sz="1200" b="1" spc="100" kern="0" dirty="0">
+              <a:rPr lang="en-US" sz="1200" b="1" kern="0" spc="100" dirty="0">
                 <a:solidFill>
                   <a:srgbClr val="17757A"/>
                 </a:solidFill>
@@ -7604,7 +7466,9 @@
       <p:sp>
         <p:nvSpPr>
           <p:cNvPr id="3" name="Text 1"/>
-          <p:cNvSpPr/>
+          <p:cNvSpPr>
+            <a:spLocks noGrp="1"/>
+          </p:cNvSpPr>
           <p:nvPr>
             <p:ph type="title"/>
           </p:nvPr>
@@ -7626,7 +7490,7 @@
           </a:bodyPr>
           <a:lstStyle/>
           <a:p>
-            <a:pPr algn="l" indent="0" marL="0">
+            <a:pPr marL="0" indent="0" algn="l">
               <a:lnSpc>
                 <a:spcPts val="3080"/>
               </a:lnSpc>
@@ -7697,7 +7561,7 @@
           </a:bodyPr>
           <a:lstStyle/>
           <a:p>
-            <a:pPr algn="l" indent="0" marL="0">
+            <a:pPr marL="0" indent="0" algn="l">
               <a:lnSpc>
                 <a:spcPts val="2160"/>
               </a:lnSpc>
@@ -7741,7 +7605,7 @@
           </a:bodyPr>
           <a:lstStyle/>
           <a:p>
-            <a:pPr algn="l" marL="182880" indent="-182880">
+            <a:pPr marL="182880" indent="-182880" algn="l">
               <a:lnSpc>
                 <a:spcPts val="2250"/>
               </a:lnSpc>
@@ -7762,7 +7626,7 @@
             <a:endParaRPr lang="en-US" sz="1500" dirty="0"/>
           </a:p>
           <a:p>
-            <a:pPr algn="l" marL="182880" indent="-182880">
+            <a:pPr marL="182880" indent="-182880" algn="l">
               <a:lnSpc>
                 <a:spcPts val="2250"/>
               </a:lnSpc>
@@ -7783,7 +7647,7 @@
             <a:endParaRPr lang="en-US" sz="1500" dirty="0"/>
           </a:p>
           <a:p>
-            <a:pPr algn="l" marL="182880" indent="-182880">
+            <a:pPr marL="182880" indent="-182880" algn="l">
               <a:lnSpc>
                 <a:spcPts val="2250"/>
               </a:lnSpc>
@@ -7804,7 +7668,7 @@
             <a:endParaRPr lang="en-US" sz="1500" dirty="0"/>
           </a:p>
           <a:p>
-            <a:pPr algn="l" marL="182880" indent="-182880">
+            <a:pPr marL="182880" indent="-182880" algn="l">
               <a:lnSpc>
                 <a:spcPts val="2250"/>
               </a:lnSpc>
@@ -7876,7 +7740,7 @@
           </a:bodyPr>
           <a:lstStyle/>
           <a:p>
-            <a:pPr algn="l" indent="0" marL="0">
+            <a:pPr marL="0" indent="0" algn="l">
               <a:lnSpc>
                 <a:spcPts val="2160"/>
               </a:lnSpc>
@@ -7913,15 +7777,27 @@
         </p:nvGraphicFramePr>
         <p:xfrm>
           <a:off x="6468882" y="2343772"/>
-          <a:ext cx="4650563" cy="2469194"/>
+          <a:ext cx="4650563" cy="2469192"/>
         </p:xfrm>
         <a:graphic>
           <a:graphicData uri="http://schemas.openxmlformats.org/drawingml/2006/table">
             <a:tbl>
               <a:tblPr/>
               <a:tblGrid>
-                <a:gridCol w="2883349"/>
-                <a:gridCol w="1767214"/>
+                <a:gridCol w="2883349">
+                  <a:extLst>
+                    <a:ext uri="{9D8B030D-6E8A-4147-A177-3AD203B41FA5}">
+                      <a16:colId xmlns:a16="http://schemas.microsoft.com/office/drawing/2014/main" val="20000"/>
+                    </a:ext>
+                  </a:extLst>
+                </a:gridCol>
+                <a:gridCol w="1767214">
+                  <a:extLst>
+                    <a:ext uri="{9D8B030D-6E8A-4147-A177-3AD203B41FA5}">
+                      <a16:colId xmlns:a16="http://schemas.microsoft.com/office/drawing/2014/main" val="20001"/>
+                    </a:ext>
+                  </a:extLst>
+                </a:gridCol>
               </a:tblGrid>
               <a:tr h="411532">
                 <a:tc>
@@ -7929,7 +7805,7 @@
                     <a:bodyPr/>
                     <a:lstStyle/>
                     <a:p>
-                      <a:pPr indent="0" marL="0">
+                      <a:pPr marL="0" indent="0">
                         <a:lnSpc>
                           <a:spcPts val="2100"/>
                         </a:lnSpc>
@@ -7953,7 +7829,7 @@
                       </a:endParaRPr>
                     </a:p>
                   </a:txBody>
-                  <a:tcPr marL="66675" marR="66675" marT="66675" marB="66675" anchor="t">
+                  <a:tcPr marL="66675" marR="66675" marT="66675" marB="66675">
                     <a:lnL w="12700" cap="flat" cmpd="sng" algn="ctr">
                       <a:solidFill>
                         <a:srgbClr val="CBCAC6"/>
@@ -8000,7 +7876,7 @@
                     <a:bodyPr/>
                     <a:lstStyle/>
                     <a:p>
-                      <a:pPr algn="r" indent="0" marL="0">
+                      <a:pPr marL="0" indent="0" algn="r">
                         <a:lnSpc>
                           <a:spcPts val="2100"/>
                         </a:lnSpc>
@@ -8024,7 +7900,7 @@
                       </a:endParaRPr>
                     </a:p>
                   </a:txBody>
-                  <a:tcPr marL="66675" marR="66675" marT="66675" marB="66675" anchor="t">
+                  <a:tcPr marL="66675" marR="66675" marT="66675" marB="66675">
                     <a:lnL w="12700" cap="flat" cmpd="sng" algn="ctr">
                       <a:solidFill>
                         <a:srgbClr val="141E34"/>
@@ -8066,6 +7942,11 @@
                     </a:solidFill>
                   </a:tcPr>
                 </a:tc>
+                <a:extLst>
+                  <a:ext uri="{0D108BD9-81ED-4DB2-BD59-A6C34878D82A}">
+                    <a16:rowId xmlns:a16="http://schemas.microsoft.com/office/drawing/2014/main" val="10000"/>
+                  </a:ext>
+                </a:extLst>
               </a:tr>
               <a:tr h="411532">
                 <a:tc>
@@ -8073,7 +7954,7 @@
                     <a:bodyPr/>
                     <a:lstStyle/>
                     <a:p>
-                      <a:pPr indent="0" marL="0">
+                      <a:pPr marL="0" indent="0">
                         <a:lnSpc>
                           <a:spcPts val="2100"/>
                         </a:lnSpc>
@@ -8097,7 +7978,7 @@
                       </a:endParaRPr>
                     </a:p>
                   </a:txBody>
-                  <a:tcPr marL="66675" marR="66675" marT="66675" marB="66675" anchor="t">
+                  <a:tcPr marL="66675" marR="66675" marT="66675" marB="66675">
                     <a:lnL w="12700" cap="flat" cmpd="sng" algn="ctr">
                       <a:solidFill>
                         <a:srgbClr val="CBCAC6"/>
@@ -8141,7 +8022,7 @@
                     <a:bodyPr/>
                     <a:lstStyle/>
                     <a:p>
-                      <a:pPr algn="r" indent="0" marL="0">
+                      <a:pPr marL="0" indent="0" algn="r">
                         <a:lnSpc>
                           <a:spcPts val="2100"/>
                         </a:lnSpc>
@@ -8165,7 +8046,7 @@
                       </a:endParaRPr>
                     </a:p>
                   </a:txBody>
-                  <a:tcPr marL="66675" marR="66675" marT="66675" marB="66675" anchor="t">
+                  <a:tcPr marL="66675" marR="66675" marT="66675" marB="66675">
                     <a:lnL w="12700" cap="flat" cmpd="sng" algn="ctr">
                       <a:solidFill>
                         <a:srgbClr val="CBCAC6"/>
@@ -8204,6 +8085,11 @@
                     </a:lnB>
                   </a:tcPr>
                 </a:tc>
+                <a:extLst>
+                  <a:ext uri="{0D108BD9-81ED-4DB2-BD59-A6C34878D82A}">
+                    <a16:rowId xmlns:a16="http://schemas.microsoft.com/office/drawing/2014/main" val="10001"/>
+                  </a:ext>
+                </a:extLst>
               </a:tr>
               <a:tr h="411532">
                 <a:tc>
@@ -8211,7 +8097,7 @@
                     <a:bodyPr/>
                     <a:lstStyle/>
                     <a:p>
-                      <a:pPr indent="0" marL="0">
+                      <a:pPr marL="0" indent="0">
                         <a:lnSpc>
                           <a:spcPts val="2100"/>
                         </a:lnSpc>
@@ -8235,7 +8121,7 @@
                       </a:endParaRPr>
                     </a:p>
                   </a:txBody>
-                  <a:tcPr marL="66675" marR="66675" marT="66675" marB="66675" anchor="t">
+                  <a:tcPr marL="66675" marR="66675" marT="66675" marB="66675">
                     <a:lnL w="12700" cap="flat" cmpd="sng" algn="ctr">
                       <a:solidFill>
                         <a:srgbClr val="CBCAC6"/>
@@ -8279,7 +8165,7 @@
                     <a:bodyPr/>
                     <a:lstStyle/>
                     <a:p>
-                      <a:pPr algn="r" indent="0" marL="0">
+                      <a:pPr marL="0" indent="0" algn="r">
                         <a:lnSpc>
                           <a:spcPts val="2100"/>
                         </a:lnSpc>
@@ -8303,7 +8189,7 @@
                       </a:endParaRPr>
                     </a:p>
                   </a:txBody>
-                  <a:tcPr marL="66675" marR="66675" marT="66675" marB="66675" anchor="t">
+                  <a:tcPr marL="66675" marR="66675" marT="66675" marB="66675">
                     <a:lnL w="12700" cap="flat" cmpd="sng" algn="ctr">
                       <a:solidFill>
                         <a:srgbClr val="CBCAC6"/>
@@ -8342,6 +8228,11 @@
                     </a:lnB>
                   </a:tcPr>
                 </a:tc>
+                <a:extLst>
+                  <a:ext uri="{0D108BD9-81ED-4DB2-BD59-A6C34878D82A}">
+                    <a16:rowId xmlns:a16="http://schemas.microsoft.com/office/drawing/2014/main" val="10002"/>
+                  </a:ext>
+                </a:extLst>
               </a:tr>
               <a:tr h="411532">
                 <a:tc>
@@ -8349,7 +8240,7 @@
                     <a:bodyPr/>
                     <a:lstStyle/>
                     <a:p>
-                      <a:pPr indent="0" marL="0">
+                      <a:pPr marL="0" indent="0">
                         <a:lnSpc>
                           <a:spcPts val="2100"/>
                         </a:lnSpc>
@@ -8373,7 +8264,7 @@
                       </a:endParaRPr>
                     </a:p>
                   </a:txBody>
-                  <a:tcPr marL="66675" marR="66675" marT="66675" marB="66675" anchor="t">
+                  <a:tcPr marL="66675" marR="66675" marT="66675" marB="66675">
                     <a:lnL w="12700" cap="flat" cmpd="sng" algn="ctr">
                       <a:solidFill>
                         <a:srgbClr val="CBCAC6"/>
@@ -8417,7 +8308,7 @@
                     <a:bodyPr/>
                     <a:lstStyle/>
                     <a:p>
-                      <a:pPr algn="r" indent="0" marL="0">
+                      <a:pPr marL="0" indent="0" algn="r">
                         <a:lnSpc>
                           <a:spcPts val="2100"/>
                         </a:lnSpc>
@@ -8441,7 +8332,7 @@
                       </a:endParaRPr>
                     </a:p>
                   </a:txBody>
-                  <a:tcPr marL="66675" marR="66675" marT="66675" marB="66675" anchor="t">
+                  <a:tcPr marL="66675" marR="66675" marT="66675" marB="66675">
                     <a:lnL w="12700" cap="flat" cmpd="sng" algn="ctr">
                       <a:solidFill>
                         <a:srgbClr val="CBCAC6"/>
@@ -8480,6 +8371,11 @@
                     </a:lnB>
                   </a:tcPr>
                 </a:tc>
+                <a:extLst>
+                  <a:ext uri="{0D108BD9-81ED-4DB2-BD59-A6C34878D82A}">
+                    <a16:rowId xmlns:a16="http://schemas.microsoft.com/office/drawing/2014/main" val="10003"/>
+                  </a:ext>
+                </a:extLst>
               </a:tr>
               <a:tr h="411532">
                 <a:tc>
@@ -8487,7 +8383,7 @@
                     <a:bodyPr/>
                     <a:lstStyle/>
                     <a:p>
-                      <a:pPr indent="0" marL="0">
+                      <a:pPr marL="0" indent="0">
                         <a:lnSpc>
                           <a:spcPts val="2100"/>
                         </a:lnSpc>
@@ -8511,7 +8407,7 @@
                       </a:endParaRPr>
                     </a:p>
                   </a:txBody>
-                  <a:tcPr marL="66675" marR="66675" marT="66675" marB="66675" anchor="t">
+                  <a:tcPr marL="66675" marR="66675" marT="66675" marB="66675">
                     <a:lnL w="12700" cap="flat" cmpd="sng" algn="ctr">
                       <a:solidFill>
                         <a:srgbClr val="CBCAC6"/>
@@ -8558,7 +8454,7 @@
                     <a:bodyPr/>
                     <a:lstStyle/>
                     <a:p>
-                      <a:pPr algn="r" indent="0" marL="0">
+                      <a:pPr marL="0" indent="0" algn="r">
                         <a:lnSpc>
                           <a:spcPts val="2100"/>
                         </a:lnSpc>
@@ -8582,7 +8478,7 @@
                       </a:endParaRPr>
                     </a:p>
                   </a:txBody>
-                  <a:tcPr marL="66675" marR="66675" marT="66675" marB="66675" anchor="t">
+                  <a:tcPr marL="66675" marR="66675" marT="66675" marB="66675">
                     <a:lnL w="12700" cap="flat" cmpd="sng" algn="ctr">
                       <a:solidFill>
                         <a:srgbClr val="B1BCBB"/>
@@ -8624,6 +8520,11 @@
                     </a:solidFill>
                   </a:tcPr>
                 </a:tc>
+                <a:extLst>
+                  <a:ext uri="{0D108BD9-81ED-4DB2-BD59-A6C34878D82A}">
+                    <a16:rowId xmlns:a16="http://schemas.microsoft.com/office/drawing/2014/main" val="10004"/>
+                  </a:ext>
+                </a:extLst>
               </a:tr>
               <a:tr h="411532">
                 <a:tc>
@@ -8631,7 +8532,7 @@
                     <a:bodyPr/>
                     <a:lstStyle/>
                     <a:p>
-                      <a:pPr indent="0" marL="0">
+                      <a:pPr marL="0" indent="0">
                         <a:lnSpc>
                           <a:spcPts val="2100"/>
                         </a:lnSpc>
@@ -8655,7 +8556,7 @@
                       </a:endParaRPr>
                     </a:p>
                   </a:txBody>
-                  <a:tcPr marL="66675" marR="66675" marT="66675" marB="66675" anchor="t">
+                  <a:tcPr marL="66675" marR="66675" marT="66675" marB="66675">
                     <a:lnL w="12700" cap="flat" cmpd="sng" algn="ctr">
                       <a:solidFill>
                         <a:srgbClr val="CBCAC6"/>
@@ -8699,7 +8600,7 @@
                     <a:bodyPr/>
                     <a:lstStyle/>
                     <a:p>
-                      <a:pPr algn="r" indent="0" marL="0">
+                      <a:pPr marL="0" indent="0" algn="r">
                         <a:lnSpc>
                           <a:spcPts val="2100"/>
                         </a:lnSpc>
@@ -8723,7 +8624,7 @@
                       </a:endParaRPr>
                     </a:p>
                   </a:txBody>
-                  <a:tcPr marL="66675" marR="66675" marT="66675" marB="66675" anchor="t">
+                  <a:tcPr marL="66675" marR="66675" marT="66675" marB="66675">
                     <a:lnL w="12700" cap="flat" cmpd="sng" algn="ctr">
                       <a:solidFill>
                         <a:srgbClr val="CBCAC6"/>
@@ -8762,6 +8663,11 @@
                     </a:lnB>
                   </a:tcPr>
                 </a:tc>
+                <a:extLst>
+                  <a:ext uri="{0D108BD9-81ED-4DB2-BD59-A6C34878D82A}">
+                    <a16:rowId xmlns:a16="http://schemas.microsoft.com/office/drawing/2014/main" val="10005"/>
+                  </a:ext>
+                </a:extLst>
               </a:tr>
             </a:tbl>
           </a:graphicData>
@@ -8790,7 +8696,7 @@
           </a:bodyPr>
           <a:lstStyle/>
           <a:p>
-            <a:pPr algn="l" indent="0" marL="0">
+            <a:pPr marL="0" indent="0" algn="l">
               <a:lnSpc>
                 <a:spcPts val="1680"/>
               </a:lnSpc>
@@ -8834,7 +8740,7 @@
           </a:bodyPr>
           <a:lstStyle/>
           <a:p>
-            <a:pPr algn="l" indent="0" marL="0">
+            <a:pPr marL="0" indent="0" algn="l">
               <a:lnSpc>
                 <a:spcPts val="1680"/>
               </a:lnSpc>
@@ -8878,7 +8784,7 @@
           </a:bodyPr>
           <a:lstStyle/>
           <a:p>
-            <a:pPr algn="r" indent="0" marL="0">
+            <a:pPr marL="0" indent="0" algn="r">
               <a:lnSpc>
                 <a:spcPts val="1680"/>
               </a:lnSpc>
@@ -8915,6 +8821,7 @@
         <a:solidFill>
           <a:srgbClr val="F6F4EE"/>
         </a:solidFill>
+        <a:effectLst/>
       </p:bgPr>
     </p:bg>
     <p:spTree>
@@ -8954,14 +8861,14 @@
           </a:bodyPr>
           <a:lstStyle/>
           <a:p>
-            <a:pPr algn="l" indent="0" marL="0">
+            <a:pPr marL="0" indent="0" algn="l">
               <a:lnSpc>
                 <a:spcPts val="1680"/>
               </a:lnSpc>
               <a:buNone/>
             </a:pPr>
             <a:r>
-              <a:rPr lang="en-US" sz="1200" b="1" spc="100" kern="0" dirty="0">
+              <a:rPr lang="en-US" sz="1200" b="1" kern="0" spc="100" dirty="0">
                 <a:solidFill>
                   <a:srgbClr val="17757A"/>
                 </a:solidFill>
@@ -8978,7 +8885,9 @@
       <p:sp>
         <p:nvSpPr>
           <p:cNvPr id="3" name="Text 1"/>
-          <p:cNvSpPr/>
+          <p:cNvSpPr>
+            <a:spLocks noGrp="1"/>
+          </p:cNvSpPr>
           <p:nvPr>
             <p:ph type="title"/>
           </p:nvPr>
@@ -9000,7 +8909,7 @@
           </a:bodyPr>
           <a:lstStyle/>
           <a:p>
-            <a:pPr algn="l" indent="0" marL="0">
+            <a:pPr marL="0" indent="0" algn="l">
               <a:lnSpc>
                 <a:spcPts val="3080"/>
               </a:lnSpc>
@@ -9071,7 +8980,7 @@
           </a:bodyPr>
           <a:lstStyle/>
           <a:p>
-            <a:pPr algn="l" indent="0" marL="0">
+            <a:pPr marL="0" indent="0" algn="l">
               <a:lnSpc>
                 <a:spcPts val="2160"/>
               </a:lnSpc>
@@ -9115,7 +9024,7 @@
           </a:bodyPr>
           <a:lstStyle/>
           <a:p>
-            <a:pPr algn="l" indent="0" marL="0">
+            <a:pPr marL="0" indent="0" algn="l">
               <a:lnSpc>
                 <a:spcPts val="2100"/>
               </a:lnSpc>
@@ -9186,7 +9095,7 @@
           </a:bodyPr>
           <a:lstStyle/>
           <a:p>
-            <a:pPr algn="l" indent="0" marL="0">
+            <a:pPr marL="0" indent="0" algn="l">
               <a:lnSpc>
                 <a:spcPts val="2160"/>
               </a:lnSpc>
@@ -9230,7 +9139,7 @@
           </a:bodyPr>
           <a:lstStyle/>
           <a:p>
-            <a:pPr algn="l" indent="0" marL="0">
+            <a:pPr marL="0" indent="0" algn="l">
               <a:lnSpc>
                 <a:spcPts val="2100"/>
               </a:lnSpc>
@@ -9301,7 +9210,7 @@
           </a:bodyPr>
           <a:lstStyle/>
           <a:p>
-            <a:pPr algn="l" indent="0" marL="0">
+            <a:pPr marL="0" indent="0" algn="l">
               <a:lnSpc>
                 <a:spcPts val="2160"/>
               </a:lnSpc>
@@ -9345,7 +9254,7 @@
           </a:bodyPr>
           <a:lstStyle/>
           <a:p>
-            <a:pPr algn="l" indent="0" marL="0">
+            <a:pPr marL="0" indent="0" algn="l">
               <a:lnSpc>
                 <a:spcPts val="2100"/>
               </a:lnSpc>
@@ -9416,7 +9325,7 @@
           </a:bodyPr>
           <a:lstStyle/>
           <a:p>
-            <a:pPr algn="l" indent="0" marL="0">
+            <a:pPr marL="0" indent="0" algn="l">
               <a:lnSpc>
                 <a:spcPts val="2160"/>
               </a:lnSpc>
@@ -9460,7 +9369,7 @@
           </a:bodyPr>
           <a:lstStyle/>
           <a:p>
-            <a:pPr algn="l" indent="0" marL="0">
+            <a:pPr marL="0" indent="0" algn="l">
               <a:lnSpc>
                 <a:spcPts val="2100"/>
               </a:lnSpc>
@@ -9504,7 +9413,7 @@
           </a:bodyPr>
           <a:lstStyle/>
           <a:p>
-            <a:pPr algn="l" indent="0" marL="0">
+            <a:pPr marL="0" indent="0" algn="l">
               <a:lnSpc>
                 <a:spcPts val="1680"/>
               </a:lnSpc>
@@ -9548,7 +9457,7 @@
           </a:bodyPr>
           <a:lstStyle/>
           <a:p>
-            <a:pPr algn="r" indent="0" marL="0">
+            <a:pPr marL="0" indent="0" algn="r">
               <a:lnSpc>
                 <a:spcPts val="1680"/>
               </a:lnSpc>
@@ -9585,6 +9494,7 @@
         <a:solidFill>
           <a:srgbClr val="F6F4EE"/>
         </a:solidFill>
+        <a:effectLst/>
       </p:bgPr>
     </p:bg>
     <p:spTree>
@@ -9624,14 +9534,14 @@
           </a:bodyPr>
           <a:lstStyle/>
           <a:p>
-            <a:pPr algn="l" indent="0" marL="0">
+            <a:pPr marL="0" indent="0" algn="l">
               <a:lnSpc>
                 <a:spcPts val="1680"/>
               </a:lnSpc>
               <a:buNone/>
             </a:pPr>
             <a:r>
-              <a:rPr lang="en-US" sz="1200" b="1" spc="100" kern="0" dirty="0">
+              <a:rPr lang="en-US" sz="1200" b="1" kern="0" spc="100" dirty="0">
                 <a:solidFill>
                   <a:srgbClr val="17757A"/>
                 </a:solidFill>
@@ -9648,7 +9558,9 @@
       <p:sp>
         <p:nvSpPr>
           <p:cNvPr id="3" name="Text 1"/>
-          <p:cNvSpPr/>
+          <p:cNvSpPr>
+            <a:spLocks noGrp="1"/>
+          </p:cNvSpPr>
           <p:nvPr>
             <p:ph type="title"/>
           </p:nvPr>
@@ -9670,7 +9582,7 @@
           </a:bodyPr>
           <a:lstStyle/>
           <a:p>
-            <a:pPr algn="l" indent="0" marL="0">
+            <a:pPr marL="0" indent="0" algn="l">
               <a:lnSpc>
                 <a:spcPts val="3080"/>
               </a:lnSpc>
@@ -9714,7 +9626,7 @@
           </a:bodyPr>
           <a:lstStyle/>
           <a:p>
-            <a:pPr algn="l" indent="0" marL="0">
+            <a:pPr marL="0" indent="0" algn="l">
               <a:lnSpc>
                 <a:spcPts val="2100"/>
               </a:lnSpc>
@@ -9785,7 +9697,7 @@
           </a:bodyPr>
           <a:lstStyle/>
           <a:p>
-            <a:pPr algn="l" indent="0" marL="0">
+            <a:pPr marL="0" indent="0" algn="l">
               <a:lnSpc>
                 <a:spcPts val="2160"/>
               </a:lnSpc>
@@ -9829,7 +9741,7 @@
           </a:bodyPr>
           <a:lstStyle/>
           <a:p>
-            <a:pPr algn="l" indent="0" marL="0">
+            <a:pPr marL="0" indent="0" algn="l">
               <a:lnSpc>
                 <a:spcPts val="2100"/>
               </a:lnSpc>
@@ -9900,7 +9812,7 @@
           </a:bodyPr>
           <a:lstStyle/>
           <a:p>
-            <a:pPr algn="l" indent="0" marL="0">
+            <a:pPr marL="0" indent="0" algn="l">
               <a:lnSpc>
                 <a:spcPts val="2160"/>
               </a:lnSpc>
@@ -9944,7 +9856,7 @@
           </a:bodyPr>
           <a:lstStyle/>
           <a:p>
-            <a:pPr algn="l" indent="0" marL="0">
+            <a:pPr marL="0" indent="0" algn="l">
               <a:lnSpc>
                 <a:spcPts val="2100"/>
               </a:lnSpc>
@@ -10015,7 +9927,7 @@
           </a:bodyPr>
           <a:lstStyle/>
           <a:p>
-            <a:pPr algn="l" indent="0" marL="0">
+            <a:pPr marL="0" indent="0" algn="l">
               <a:lnSpc>
                 <a:spcPts val="2160"/>
               </a:lnSpc>
@@ -10059,7 +9971,7 @@
           </a:bodyPr>
           <a:lstStyle/>
           <a:p>
-            <a:pPr algn="l" indent="0" marL="0">
+            <a:pPr marL="0" indent="0" algn="l">
               <a:lnSpc>
                 <a:spcPts val="2100"/>
               </a:lnSpc>
@@ -10103,7 +10015,7 @@
           </a:bodyPr>
           <a:lstStyle/>
           <a:p>
-            <a:pPr algn="l" indent="0" marL="0">
+            <a:pPr marL="0" indent="0" algn="l">
               <a:lnSpc>
                 <a:spcPts val="1680"/>
               </a:lnSpc>
@@ -10147,7 +10059,7 @@
           </a:bodyPr>
           <a:lstStyle/>
           <a:p>
-            <a:pPr algn="r" indent="0" marL="0">
+            <a:pPr marL="0" indent="0" algn="r">
               <a:lnSpc>
                 <a:spcPts val="1680"/>
               </a:lnSpc>
@@ -10184,6 +10096,7 @@
         <a:solidFill>
           <a:srgbClr val="F6F4EE"/>
         </a:solidFill>
+        <a:effectLst/>
       </p:bgPr>
     </p:bg>
     <p:spTree>
@@ -10223,14 +10136,14 @@
           </a:bodyPr>
           <a:lstStyle/>
           <a:p>
-            <a:pPr algn="l" indent="0" marL="0">
+            <a:pPr marL="0" indent="0" algn="l">
               <a:lnSpc>
                 <a:spcPts val="1680"/>
               </a:lnSpc>
               <a:buNone/>
             </a:pPr>
             <a:r>
-              <a:rPr lang="en-US" sz="1200" b="1" spc="100" kern="0" dirty="0">
+              <a:rPr lang="en-US" sz="1200" b="1" kern="0" spc="100" dirty="0">
                 <a:solidFill>
                   <a:srgbClr val="17757A"/>
                 </a:solidFill>
@@ -10247,7 +10160,9 @@
       <p:sp>
         <p:nvSpPr>
           <p:cNvPr id="3" name="Text 1"/>
-          <p:cNvSpPr/>
+          <p:cNvSpPr>
+            <a:spLocks noGrp="1"/>
+          </p:cNvSpPr>
           <p:nvPr>
             <p:ph type="title"/>
           </p:nvPr>
@@ -10269,7 +10184,7 @@
           </a:bodyPr>
           <a:lstStyle/>
           <a:p>
-            <a:pPr algn="l" indent="0" marL="0">
+            <a:pPr marL="0" indent="0" algn="l">
               <a:lnSpc>
                 <a:spcPts val="3080"/>
               </a:lnSpc>
@@ -10340,7 +10255,7 @@
           </a:bodyPr>
           <a:lstStyle/>
           <a:p>
-            <a:pPr algn="l" indent="0" marL="0">
+            <a:pPr marL="0" indent="0" algn="l">
               <a:lnSpc>
                 <a:spcPts val="2160"/>
               </a:lnSpc>
@@ -10384,7 +10299,7 @@
           </a:bodyPr>
           <a:lstStyle/>
           <a:p>
-            <a:pPr algn="l" marL="182880" indent="-182880">
+            <a:pPr marL="182880" indent="-182880" algn="l">
               <a:lnSpc>
                 <a:spcPts val="2250"/>
               </a:lnSpc>
@@ -10405,7 +10320,7 @@
             <a:endParaRPr lang="en-US" sz="1500" dirty="0"/>
           </a:p>
           <a:p>
-            <a:pPr algn="l" marL="182880" indent="-182880">
+            <a:pPr marL="182880" indent="-182880" algn="l">
               <a:lnSpc>
                 <a:spcPts val="2250"/>
               </a:lnSpc>
@@ -10426,7 +10341,7 @@
             <a:endParaRPr lang="en-US" sz="1500" dirty="0"/>
           </a:p>
           <a:p>
-            <a:pPr algn="l" marL="182880" indent="-182880">
+            <a:pPr marL="182880" indent="-182880" algn="l">
               <a:lnSpc>
                 <a:spcPts val="2250"/>
               </a:lnSpc>
@@ -10447,7 +10362,7 @@
             <a:endParaRPr lang="en-US" sz="1500" dirty="0"/>
           </a:p>
           <a:p>
-            <a:pPr algn="l" marL="182880" indent="-182880">
+            <a:pPr marL="182880" indent="-182880" algn="l">
               <a:lnSpc>
                 <a:spcPts val="2250"/>
               </a:lnSpc>
@@ -10468,7 +10383,7 @@
             <a:endParaRPr lang="en-US" sz="1500" dirty="0"/>
           </a:p>
           <a:p>
-            <a:pPr algn="l" marL="182880" indent="-182880">
+            <a:pPr marL="182880" indent="-182880" algn="l">
               <a:lnSpc>
                 <a:spcPts val="2250"/>
               </a:lnSpc>
@@ -10540,7 +10455,7 @@
           </a:bodyPr>
           <a:lstStyle/>
           <a:p>
-            <a:pPr algn="l" indent="0" marL="0">
+            <a:pPr marL="0" indent="0" algn="l">
               <a:lnSpc>
                 <a:spcPts val="2160"/>
               </a:lnSpc>
@@ -10584,7 +10499,7 @@
           </a:bodyPr>
           <a:lstStyle/>
           <a:p>
-            <a:pPr algn="l" marL="182880" indent="-182880">
+            <a:pPr marL="182880" indent="-182880" algn="l">
               <a:lnSpc>
                 <a:spcPts val="2250"/>
               </a:lnSpc>
@@ -10605,7 +10520,7 @@
             <a:endParaRPr lang="en-US" sz="1500" dirty="0"/>
           </a:p>
           <a:p>
-            <a:pPr algn="l" marL="182880" indent="-182880">
+            <a:pPr marL="182880" indent="-182880" algn="l">
               <a:lnSpc>
                 <a:spcPts val="2250"/>
               </a:lnSpc>
@@ -10626,7 +10541,7 @@
             <a:endParaRPr lang="en-US" sz="1500" dirty="0"/>
           </a:p>
           <a:p>
-            <a:pPr algn="l" marL="182880" indent="-182880">
+            <a:pPr marL="182880" indent="-182880" algn="l">
               <a:lnSpc>
                 <a:spcPts val="2250"/>
               </a:lnSpc>
@@ -10647,7 +10562,7 @@
             <a:endParaRPr lang="en-US" sz="1500" dirty="0"/>
           </a:p>
           <a:p>
-            <a:pPr algn="l" marL="182880" indent="-182880">
+            <a:pPr marL="182880" indent="-182880" algn="l">
               <a:lnSpc>
                 <a:spcPts val="2250"/>
               </a:lnSpc>
@@ -10668,7 +10583,7 @@
             <a:endParaRPr lang="en-US" sz="1500" dirty="0"/>
           </a:p>
           <a:p>
-            <a:pPr algn="l" marL="182880" indent="-182880">
+            <a:pPr marL="182880" indent="-182880" algn="l">
               <a:lnSpc>
                 <a:spcPts val="2250"/>
               </a:lnSpc>
@@ -10717,7 +10632,7 @@
           </a:bodyPr>
           <a:lstStyle/>
           <a:p>
-            <a:pPr algn="l" indent="0" marL="0">
+            <a:pPr marL="0" indent="0" algn="l">
               <a:lnSpc>
                 <a:spcPts val="2100"/>
               </a:lnSpc>
@@ -10761,7 +10676,7 @@
           </a:bodyPr>
           <a:lstStyle/>
           <a:p>
-            <a:pPr algn="l" indent="0" marL="0">
+            <a:pPr marL="0" indent="0" algn="l">
               <a:lnSpc>
                 <a:spcPts val="1680"/>
               </a:lnSpc>
@@ -10805,7 +10720,7 @@
           </a:bodyPr>
           <a:lstStyle/>
           <a:p>
-            <a:pPr algn="r" indent="0" marL="0">
+            <a:pPr marL="0" indent="0" algn="r">
               <a:lnSpc>
                 <a:spcPts val="1680"/>
               </a:lnSpc>
@@ -10842,6 +10757,7 @@
         <a:solidFill>
           <a:srgbClr val="F6F4EE"/>
         </a:solidFill>
+        <a:effectLst/>
       </p:bgPr>
     </p:bg>
     <p:spTree>
@@ -10881,14 +10797,14 @@
           </a:bodyPr>
           <a:lstStyle/>
           <a:p>
-            <a:pPr algn="l" indent="0" marL="0">
+            <a:pPr marL="0" indent="0" algn="l">
               <a:lnSpc>
                 <a:spcPts val="1680"/>
               </a:lnSpc>
               <a:buNone/>
             </a:pPr>
             <a:r>
-              <a:rPr lang="en-US" sz="1200" b="1" spc="100" kern="0" dirty="0">
+              <a:rPr lang="en-US" sz="1200" b="1" kern="0" spc="100" dirty="0">
                 <a:solidFill>
                   <a:srgbClr val="17757A"/>
                 </a:solidFill>
@@ -10905,7 +10821,9 @@
       <p:sp>
         <p:nvSpPr>
           <p:cNvPr id="3" name="Text 1"/>
-          <p:cNvSpPr/>
+          <p:cNvSpPr>
+            <a:spLocks noGrp="1"/>
+          </p:cNvSpPr>
           <p:nvPr>
             <p:ph type="title"/>
           </p:nvPr>
@@ -10927,7 +10845,7 @@
           </a:bodyPr>
           <a:lstStyle/>
           <a:p>
-            <a:pPr algn="l" indent="0" marL="0">
+            <a:pPr marL="0" indent="0" algn="l">
               <a:lnSpc>
                 <a:spcPts val="3080"/>
               </a:lnSpc>
@@ -10998,7 +10916,7 @@
           </a:bodyPr>
           <a:lstStyle/>
           <a:p>
-            <a:pPr algn="l" indent="0" marL="0">
+            <a:pPr marL="0" indent="0" algn="l">
               <a:lnSpc>
                 <a:spcPts val="2100"/>
               </a:lnSpc>
@@ -11042,7 +10960,7 @@
           </a:bodyPr>
           <a:lstStyle/>
           <a:p>
-            <a:pPr algn="l" indent="0" marL="0">
+            <a:pPr marL="0" indent="0" algn="l">
               <a:lnSpc>
                 <a:spcPts val="1680"/>
               </a:lnSpc>
@@ -11065,15 +10983,15 @@
       </p:sp>
       <p:pic>
         <p:nvPicPr>
-          <p:cNvPr id="7" name="Image 0" descr="arrow-right">    </p:cNvPr>
+          <p:cNvPr id="7" name="Image 0" descr="arrow-right"/>
           <p:cNvPicPr>
             <a:picLocks noChangeAspect="1"/>
           </p:cNvPicPr>
           <p:nvPr/>
         </p:nvPicPr>
         <p:blipFill>
-          <a:blip r:embed="rId1"/>
-          <a:srcRect l="-5" r="-5" t="0" b="0"/>
+          <a:blip r:embed="rId3"/>
+          <a:srcRect l="-5" r="-5"/>
           <a:stretch/>
         </p:blipFill>
         <p:spPr>
@@ -11131,7 +11049,7 @@
           </a:bodyPr>
           <a:lstStyle/>
           <a:p>
-            <a:pPr algn="l" indent="0" marL="0">
+            <a:pPr marL="0" indent="0" algn="l">
               <a:lnSpc>
                 <a:spcPts val="2100"/>
               </a:lnSpc>
@@ -11175,7 +11093,7 @@
           </a:bodyPr>
           <a:lstStyle/>
           <a:p>
-            <a:pPr algn="l" indent="0" marL="0">
+            <a:pPr marL="0" indent="0" algn="l">
               <a:lnSpc>
                 <a:spcPts val="1680"/>
               </a:lnSpc>
@@ -11198,15 +11116,15 @@
       </p:sp>
       <p:pic>
         <p:nvPicPr>
-          <p:cNvPr id="11" name="Image 1" descr="arrow-right">    </p:cNvPr>
+          <p:cNvPr id="11" name="Image 1" descr="arrow-right"/>
           <p:cNvPicPr>
             <a:picLocks noChangeAspect="1"/>
           </p:cNvPicPr>
           <p:nvPr/>
         </p:nvPicPr>
         <p:blipFill>
-          <a:blip r:embed="rId2"/>
-          <a:srcRect l="-5" r="-5" t="0" b="0"/>
+          <a:blip r:embed="rId3"/>
+          <a:srcRect l="-5" r="-5"/>
           <a:stretch/>
         </p:blipFill>
         <p:spPr>
@@ -11264,7 +11182,7 @@
           </a:bodyPr>
           <a:lstStyle/>
           <a:p>
-            <a:pPr algn="l" indent="0" marL="0">
+            <a:pPr marL="0" indent="0" algn="l">
               <a:lnSpc>
                 <a:spcPts val="2100"/>
               </a:lnSpc>
@@ -11308,7 +11226,7 @@
           </a:bodyPr>
           <a:lstStyle/>
           <a:p>
-            <a:pPr algn="l" indent="0" marL="0">
+            <a:pPr marL="0" indent="0" algn="l">
               <a:lnSpc>
                 <a:spcPts val="1680"/>
               </a:lnSpc>
@@ -11331,7 +11249,7 @@
       </p:sp>
       <p:pic>
         <p:nvPicPr>
-          <p:cNvPr id="15" name="Image 2" descr="arrow-right">    </p:cNvPr>
+          <p:cNvPr id="15" name="Image 2" descr="arrow-right"/>
           <p:cNvPicPr>
             <a:picLocks noChangeAspect="1"/>
           </p:cNvPicPr>
@@ -11339,7 +11257,7 @@
         </p:nvPicPr>
         <p:blipFill>
           <a:blip r:embed="rId3"/>
-          <a:srcRect l="-5" r="-5" t="0" b="0"/>
+          <a:srcRect l="-5" r="-5"/>
           <a:stretch/>
         </p:blipFill>
         <p:spPr>
@@ -11397,7 +11315,7 @@
           </a:bodyPr>
           <a:lstStyle/>
           <a:p>
-            <a:pPr algn="l" indent="0" marL="0">
+            <a:pPr marL="0" indent="0" algn="l">
               <a:lnSpc>
                 <a:spcPts val="2100"/>
               </a:lnSpc>
@@ -11441,7 +11359,7 @@
           </a:bodyPr>
           <a:lstStyle/>
           <a:p>
-            <a:pPr algn="l" indent="0" marL="0">
+            <a:pPr marL="0" indent="0" algn="l">
               <a:lnSpc>
                 <a:spcPts val="1680"/>
               </a:lnSpc>
@@ -11464,15 +11382,15 @@
       </p:sp>
       <p:pic>
         <p:nvPicPr>
-          <p:cNvPr id="19" name="Image 3" descr="arrow-right">    </p:cNvPr>
+          <p:cNvPr id="19" name="Image 3" descr="arrow-right"/>
           <p:cNvPicPr>
             <a:picLocks noChangeAspect="1"/>
           </p:cNvPicPr>
           <p:nvPr/>
         </p:nvPicPr>
         <p:blipFill>
-          <a:blip r:embed="rId4"/>
-          <a:srcRect l="-5" r="-5" t="0" b="0"/>
+          <a:blip r:embed="rId3"/>
+          <a:srcRect l="-5" r="-5"/>
           <a:stretch/>
         </p:blipFill>
         <p:spPr>
@@ -11535,7 +11453,7 @@
           </a:bodyPr>
           <a:lstStyle/>
           <a:p>
-            <a:pPr algn="l" indent="0" marL="0">
+            <a:pPr marL="0" indent="0" algn="l">
               <a:lnSpc>
                 <a:spcPts val="2100"/>
               </a:lnSpc>
@@ -11579,7 +11497,7 @@
           </a:bodyPr>
           <a:lstStyle/>
           <a:p>
-            <a:pPr algn="l" indent="0" marL="0">
+            <a:pPr marL="0" indent="0" algn="l">
               <a:lnSpc>
                 <a:spcPts val="1680"/>
               </a:lnSpc>
@@ -11623,7 +11541,7 @@
           </a:bodyPr>
           <a:lstStyle/>
           <a:p>
-            <a:pPr algn="l" indent="0" marL="0">
+            <a:pPr marL="0" indent="0" algn="l">
               <a:lnSpc>
                 <a:spcPts val="1680"/>
               </a:lnSpc>
@@ -11694,7 +11612,7 @@
           </a:bodyPr>
           <a:lstStyle/>
           <a:p>
-            <a:pPr algn="l" indent="0" marL="0">
+            <a:pPr marL="0" indent="0" algn="l">
               <a:lnSpc>
                 <a:spcPts val="2160"/>
               </a:lnSpc>
@@ -11738,7 +11656,7 @@
           </a:bodyPr>
           <a:lstStyle/>
           <a:p>
-            <a:pPr algn="l" indent="0" marL="0">
+            <a:pPr marL="0" indent="0" algn="l">
               <a:lnSpc>
                 <a:spcPts val="2100"/>
               </a:lnSpc>
@@ -11809,7 +11727,7 @@
           </a:bodyPr>
           <a:lstStyle/>
           <a:p>
-            <a:pPr algn="l" indent="0" marL="0">
+            <a:pPr marL="0" indent="0" algn="l">
               <a:lnSpc>
                 <a:spcPts val="2160"/>
               </a:lnSpc>
@@ -11853,7 +11771,7 @@
           </a:bodyPr>
           <a:lstStyle/>
           <a:p>
-            <a:pPr algn="l" indent="0" marL="0">
+            <a:pPr marL="0" indent="0" algn="l">
               <a:lnSpc>
                 <a:spcPts val="2100"/>
               </a:lnSpc>
@@ -11924,7 +11842,7 @@
           </a:bodyPr>
           <a:lstStyle/>
           <a:p>
-            <a:pPr algn="l" indent="0" marL="0">
+            <a:pPr marL="0" indent="0" algn="l">
               <a:lnSpc>
                 <a:spcPts val="2160"/>
               </a:lnSpc>
@@ -11968,7 +11886,7 @@
           </a:bodyPr>
           <a:lstStyle/>
           <a:p>
-            <a:pPr algn="l" indent="0" marL="0">
+            <a:pPr marL="0" indent="0" algn="l">
               <a:lnSpc>
                 <a:spcPts val="2100"/>
               </a:lnSpc>
@@ -12012,7 +11930,7 @@
           </a:bodyPr>
           <a:lstStyle/>
           <a:p>
-            <a:pPr algn="l" indent="0" marL="0">
+            <a:pPr marL="0" indent="0" algn="l">
               <a:lnSpc>
                 <a:spcPts val="1680"/>
               </a:lnSpc>
@@ -12056,7 +11974,7 @@
           </a:bodyPr>
           <a:lstStyle/>
           <a:p>
-            <a:pPr algn="r" indent="0" marL="0">
+            <a:pPr marL="0" indent="0" algn="r">
               <a:lnSpc>
                 <a:spcPts val="1680"/>
               </a:lnSpc>
@@ -12093,6 +12011,7 @@
         <a:solidFill>
           <a:srgbClr val="F6F4EE"/>
         </a:solidFill>
+        <a:effectLst/>
       </p:bgPr>
     </p:bg>
     <p:spTree>
@@ -12132,14 +12051,14 @@
           </a:bodyPr>
           <a:lstStyle/>
           <a:p>
-            <a:pPr algn="l" indent="0" marL="0">
+            <a:pPr marL="0" indent="0" algn="l">
               <a:lnSpc>
                 <a:spcPts val="1680"/>
               </a:lnSpc>
               <a:buNone/>
             </a:pPr>
             <a:r>
-              <a:rPr lang="en-US" sz="1200" b="1" spc="100" kern="0" dirty="0">
+              <a:rPr lang="en-US" sz="1200" b="1" kern="0" spc="100" dirty="0">
                 <a:solidFill>
                   <a:srgbClr val="17757A"/>
                 </a:solidFill>
@@ -12156,7 +12075,9 @@
       <p:sp>
         <p:nvSpPr>
           <p:cNvPr id="3" name="Text 1"/>
-          <p:cNvSpPr/>
+          <p:cNvSpPr>
+            <a:spLocks noGrp="1"/>
+          </p:cNvSpPr>
           <p:nvPr>
             <p:ph type="title"/>
           </p:nvPr>
@@ -12178,7 +12099,7 @@
           </a:bodyPr>
           <a:lstStyle/>
           <a:p>
-            <a:pPr algn="l" indent="0" marL="0">
+            <a:pPr marL="0" indent="0" algn="l">
               <a:lnSpc>
                 <a:spcPts val="3080"/>
               </a:lnSpc>
@@ -12223,15 +12144,15 @@
       </p:sp>
       <p:pic>
         <p:nvPicPr>
-          <p:cNvPr id="5" name="Image 0" descr="Network diagram: input of 86 numbers, hidden layer of 128 neurons, hidden layer of 256 neurons, k PCA coefficients, a fixed PCA layer, and an output of 8,130 offsets">    </p:cNvPr>
+          <p:cNvPr id="5" name="Image 0" descr="Network diagram: input of 86 numbers, hidden layer of 128 neurons, hidden layer of 256 neurons, k PCA coefficients, a fixed PCA layer, and an output of 8,130 offsets"/>
           <p:cNvPicPr>
             <a:picLocks noChangeAspect="1"/>
           </p:cNvPicPr>
           <p:nvPr/>
         </p:nvPicPr>
         <p:blipFill>
-          <a:blip r:embed="rId1"/>
-          <a:srcRect l="-134" r="-134" t="0" b="0"/>
+          <a:blip r:embed="rId3"/>
+          <a:srcRect l="-134" r="-134"/>
           <a:stretch/>
         </p:blipFill>
         <p:spPr>
@@ -12294,7 +12215,7 @@
           </a:bodyPr>
           <a:lstStyle/>
           <a:p>
-            <a:pPr algn="l" indent="0" marL="0">
+            <a:pPr marL="0" indent="0" algn="l">
               <a:lnSpc>
                 <a:spcPts val="2100"/>
               </a:lnSpc>
@@ -12338,7 +12259,7 @@
           </a:bodyPr>
           <a:lstStyle/>
           <a:p>
-            <a:pPr algn="l" indent="0" marL="0">
+            <a:pPr marL="0" indent="0" algn="l">
               <a:lnSpc>
                 <a:spcPts val="1680"/>
               </a:lnSpc>
@@ -12382,7 +12303,7 @@
           </a:bodyPr>
           <a:lstStyle/>
           <a:p>
-            <a:pPr algn="r" indent="0" marL="0">
+            <a:pPr marL="0" indent="0" algn="r">
               <a:lnSpc>
                 <a:spcPts val="1680"/>
               </a:lnSpc>
@@ -12419,6 +12340,7 @@
         <a:solidFill>
           <a:srgbClr val="F6F4EE"/>
         </a:solidFill>
+        <a:effectLst/>
       </p:bgPr>
     </p:bg>
     <p:spTree>
@@ -12458,14 +12380,14 @@
           </a:bodyPr>
           <a:lstStyle/>
           <a:p>
-            <a:pPr algn="l" indent="0" marL="0">
+            <a:pPr marL="0" indent="0" algn="l">
               <a:lnSpc>
                 <a:spcPts val="1680"/>
               </a:lnSpc>
               <a:buNone/>
             </a:pPr>
             <a:r>
-              <a:rPr lang="en-US" sz="1200" b="1" spc="100" kern="0" dirty="0">
+              <a:rPr lang="en-US" sz="1200" b="1" kern="0" spc="100" dirty="0">
                 <a:solidFill>
                   <a:srgbClr val="17757A"/>
                 </a:solidFill>
@@ -12482,7 +12404,9 @@
       <p:sp>
         <p:nvSpPr>
           <p:cNvPr id="3" name="Text 1"/>
-          <p:cNvSpPr/>
+          <p:cNvSpPr>
+            <a:spLocks noGrp="1"/>
+          </p:cNvSpPr>
           <p:nvPr>
             <p:ph type="title"/>
           </p:nvPr>
@@ -12504,7 +12428,7 @@
           </a:bodyPr>
           <a:lstStyle/>
           <a:p>
-            <a:pPr algn="l" indent="0" marL="0">
+            <a:pPr marL="0" indent="0" algn="l">
               <a:lnSpc>
                 <a:spcPts val="3080"/>
               </a:lnSpc>
@@ -12541,15 +12465,27 @@
         </p:nvGraphicFramePr>
         <p:xfrm>
           <a:off x="824327" y="1758967"/>
-          <a:ext cx="10554890" cy="2880726"/>
+          <a:ext cx="10554890" cy="2880724"/>
         </p:xfrm>
         <a:graphic>
           <a:graphicData uri="http://schemas.openxmlformats.org/drawingml/2006/table">
             <a:tbl>
               <a:tblPr/>
               <a:tblGrid>
-                <a:gridCol w="2744271"/>
-                <a:gridCol w="7810619"/>
+                <a:gridCol w="2744271">
+                  <a:extLst>
+                    <a:ext uri="{9D8B030D-6E8A-4147-A177-3AD203B41FA5}">
+                      <a16:colId xmlns:a16="http://schemas.microsoft.com/office/drawing/2014/main" val="20000"/>
+                    </a:ext>
+                  </a:extLst>
+                </a:gridCol>
+                <a:gridCol w="7810619">
+                  <a:extLst>
+                    <a:ext uri="{9D8B030D-6E8A-4147-A177-3AD203B41FA5}">
+                      <a16:colId xmlns:a16="http://schemas.microsoft.com/office/drawing/2014/main" val="20001"/>
+                    </a:ext>
+                  </a:extLst>
+                </a:gridCol>
               </a:tblGrid>
               <a:tr h="411532">
                 <a:tc>
@@ -12557,7 +12493,7 @@
                     <a:bodyPr/>
                     <a:lstStyle/>
                     <a:p>
-                      <a:pPr indent="0" marL="0">
+                      <a:pPr marL="0" indent="0">
                         <a:lnSpc>
                           <a:spcPts val="2100"/>
                         </a:lnSpc>
@@ -12581,7 +12517,7 @@
                       </a:endParaRPr>
                     </a:p>
                   </a:txBody>
-                  <a:tcPr marL="66675" marR="66675" marT="66675" marB="66675" anchor="t">
+                  <a:tcPr marL="66675" marR="66675" marT="66675" marB="66675">
                     <a:lnL w="12700" cap="flat" cmpd="sng" algn="ctr">
                       <a:solidFill>
                         <a:srgbClr val="C4C3BE"/>
@@ -12628,7 +12564,7 @@
                     <a:bodyPr/>
                     <a:lstStyle/>
                     <a:p>
-                      <a:pPr indent="0" marL="0">
+                      <a:pPr marL="0" indent="0">
                         <a:lnSpc>
                           <a:spcPts val="2100"/>
                         </a:lnSpc>
@@ -12652,7 +12588,7 @@
                       </a:endParaRPr>
                     </a:p>
                   </a:txBody>
-                  <a:tcPr marL="66675" marR="66675" marT="66675" marB="66675" anchor="t">
+                  <a:tcPr marL="66675" marR="66675" marT="66675" marB="66675">
                     <a:lnL w="12700" cap="flat" cmpd="sng" algn="ctr">
                       <a:solidFill>
                         <a:srgbClr val="141E34"/>
@@ -12694,6 +12630,11 @@
                     </a:solidFill>
                   </a:tcPr>
                 </a:tc>
+                <a:extLst>
+                  <a:ext uri="{0D108BD9-81ED-4DB2-BD59-A6C34878D82A}">
+                    <a16:rowId xmlns:a16="http://schemas.microsoft.com/office/drawing/2014/main" val="10000"/>
+                  </a:ext>
+                </a:extLst>
               </a:tr>
               <a:tr h="411532">
                 <a:tc>
@@ -12701,7 +12642,7 @@
                     <a:bodyPr/>
                     <a:lstStyle/>
                     <a:p>
-                      <a:pPr indent="0" marL="0">
+                      <a:pPr marL="0" indent="0">
                         <a:lnSpc>
                           <a:spcPts val="2100"/>
                         </a:lnSpc>
@@ -12725,7 +12666,7 @@
                       </a:endParaRPr>
                     </a:p>
                   </a:txBody>
-                  <a:tcPr marL="66675" marR="66675" marT="66675" marB="66675" anchor="t">
+                  <a:tcPr marL="66675" marR="66675" marT="66675" marB="66675">
                     <a:lnL w="12700" cap="flat" cmpd="sng" algn="ctr">
                       <a:solidFill>
                         <a:srgbClr val="C4C3BE"/>
@@ -12769,7 +12710,7 @@
                     <a:bodyPr/>
                     <a:lstStyle/>
                     <a:p>
-                      <a:pPr indent="0" marL="0">
+                      <a:pPr marL="0" indent="0">
                         <a:lnSpc>
                           <a:spcPts val="2100"/>
                         </a:lnSpc>
@@ -12793,7 +12734,7 @@
                       </a:endParaRPr>
                     </a:p>
                   </a:txBody>
-                  <a:tcPr marL="66675" marR="66675" marT="66675" marB="66675" anchor="t">
+                  <a:tcPr marL="66675" marR="66675" marT="66675" marB="66675">
                     <a:lnL w="12700" cap="flat" cmpd="sng" algn="ctr">
                       <a:solidFill>
                         <a:srgbClr val="C4C3BE"/>
@@ -12832,6 +12773,11 @@
                     </a:lnB>
                   </a:tcPr>
                 </a:tc>
+                <a:extLst>
+                  <a:ext uri="{0D108BD9-81ED-4DB2-BD59-A6C34878D82A}">
+                    <a16:rowId xmlns:a16="http://schemas.microsoft.com/office/drawing/2014/main" val="10001"/>
+                  </a:ext>
+                </a:extLst>
               </a:tr>
               <a:tr h="411532">
                 <a:tc>
@@ -12839,7 +12785,7 @@
                     <a:bodyPr/>
                     <a:lstStyle/>
                     <a:p>
-                      <a:pPr indent="0" marL="0">
+                      <a:pPr marL="0" indent="0">
                         <a:lnSpc>
                           <a:spcPts val="2100"/>
                         </a:lnSpc>
@@ -12863,7 +12809,7 @@
                       </a:endParaRPr>
                     </a:p>
                   </a:txBody>
-                  <a:tcPr marL="66675" marR="66675" marT="66675" marB="66675" anchor="t">
+                  <a:tcPr marL="66675" marR="66675" marT="66675" marB="66675">
                     <a:lnL w="12700" cap="flat" cmpd="sng" algn="ctr">
                       <a:solidFill>
                         <a:srgbClr val="C4C3BE"/>
@@ -12910,7 +12856,7 @@
                     <a:bodyPr/>
                     <a:lstStyle/>
                     <a:p>
-                      <a:pPr indent="0" marL="0">
+                      <a:pPr marL="0" indent="0">
                         <a:lnSpc>
                           <a:spcPts val="2100"/>
                         </a:lnSpc>
@@ -12934,7 +12880,7 @@
                       </a:endParaRPr>
                     </a:p>
                   </a:txBody>
-                  <a:tcPr marL="66675" marR="66675" marT="66675" marB="66675" anchor="t">
+                  <a:tcPr marL="66675" marR="66675" marT="66675" marB="66675">
                     <a:lnL w="12700" cap="flat" cmpd="sng" algn="ctr">
                       <a:solidFill>
                         <a:srgbClr val="BBB8AE"/>
@@ -12976,6 +12922,11 @@
                     </a:solidFill>
                   </a:tcPr>
                 </a:tc>
+                <a:extLst>
+                  <a:ext uri="{0D108BD9-81ED-4DB2-BD59-A6C34878D82A}">
+                    <a16:rowId xmlns:a16="http://schemas.microsoft.com/office/drawing/2014/main" val="10002"/>
+                  </a:ext>
+                </a:extLst>
               </a:tr>
               <a:tr h="411532">
                 <a:tc>
@@ -12983,7 +12934,7 @@
                     <a:bodyPr/>
                     <a:lstStyle/>
                     <a:p>
-                      <a:pPr indent="0" marL="0">
+                      <a:pPr marL="0" indent="0">
                         <a:lnSpc>
                           <a:spcPts val="2100"/>
                         </a:lnSpc>
@@ -13007,7 +12958,7 @@
                       </a:endParaRPr>
                     </a:p>
                   </a:txBody>
-                  <a:tcPr marL="66675" marR="66675" marT="66675" marB="66675" anchor="t">
+                  <a:tcPr marL="66675" marR="66675" marT="66675" marB="66675">
                     <a:lnL w="12700" cap="flat" cmpd="sng" algn="ctr">
                       <a:solidFill>
                         <a:srgbClr val="C4C3BE"/>
@@ -13051,7 +13002,7 @@
                     <a:bodyPr/>
                     <a:lstStyle/>
                     <a:p>
-                      <a:pPr indent="0" marL="0">
+                      <a:pPr marL="0" indent="0">
                         <a:lnSpc>
                           <a:spcPts val="2100"/>
                         </a:lnSpc>
@@ -13075,7 +13026,7 @@
                       </a:endParaRPr>
                     </a:p>
                   </a:txBody>
-                  <a:tcPr marL="66675" marR="66675" marT="66675" marB="66675" anchor="t">
+                  <a:tcPr marL="66675" marR="66675" marT="66675" marB="66675">
                     <a:lnL w="12700" cap="flat" cmpd="sng" algn="ctr">
                       <a:solidFill>
                         <a:srgbClr val="C4C3BE"/>
@@ -13114,6 +13065,11 @@
                     </a:lnB>
                   </a:tcPr>
                 </a:tc>
+                <a:extLst>
+                  <a:ext uri="{0D108BD9-81ED-4DB2-BD59-A6C34878D82A}">
+                    <a16:rowId xmlns:a16="http://schemas.microsoft.com/office/drawing/2014/main" val="10003"/>
+                  </a:ext>
+                </a:extLst>
               </a:tr>
               <a:tr h="411532">
                 <a:tc>
@@ -13121,7 +13077,7 @@
                     <a:bodyPr/>
                     <a:lstStyle/>
                     <a:p>
-                      <a:pPr indent="0" marL="0">
+                      <a:pPr marL="0" indent="0">
                         <a:lnSpc>
                           <a:spcPts val="2100"/>
                         </a:lnSpc>
@@ -13145,7 +13101,7 @@
                       </a:endParaRPr>
                     </a:p>
                   </a:txBody>
-                  <a:tcPr marL="66675" marR="66675" marT="66675" marB="66675" anchor="t">
+                  <a:tcPr marL="66675" marR="66675" marT="66675" marB="66675">
                     <a:lnL w="12700" cap="flat" cmpd="sng" algn="ctr">
                       <a:solidFill>
                         <a:srgbClr val="C4C3BE"/>
@@ -13192,7 +13148,7 @@
                     <a:bodyPr/>
                     <a:lstStyle/>
                     <a:p>
-                      <a:pPr indent="0" marL="0">
+                      <a:pPr marL="0" indent="0">
                         <a:lnSpc>
                           <a:spcPts val="2100"/>
                         </a:lnSpc>
@@ -13216,7 +13172,7 @@
                       </a:endParaRPr>
                     </a:p>
                   </a:txBody>
-                  <a:tcPr marL="66675" marR="66675" marT="66675" marB="66675" anchor="t">
+                  <a:tcPr marL="66675" marR="66675" marT="66675" marB="66675">
                     <a:lnL w="12700" cap="flat" cmpd="sng" algn="ctr">
                       <a:solidFill>
                         <a:srgbClr val="BBB8AE"/>
@@ -13258,6 +13214,11 @@
                     </a:solidFill>
                   </a:tcPr>
                 </a:tc>
+                <a:extLst>
+                  <a:ext uri="{0D108BD9-81ED-4DB2-BD59-A6C34878D82A}">
+                    <a16:rowId xmlns:a16="http://schemas.microsoft.com/office/drawing/2014/main" val="10004"/>
+                  </a:ext>
+                </a:extLst>
               </a:tr>
               <a:tr h="411532">
                 <a:tc>
@@ -13265,7 +13226,7 @@
                     <a:bodyPr/>
                     <a:lstStyle/>
                     <a:p>
-                      <a:pPr indent="0" marL="0">
+                      <a:pPr marL="0" indent="0">
                         <a:lnSpc>
                           <a:spcPts val="2100"/>
                         </a:lnSpc>
@@ -13289,7 +13250,7 @@
                       </a:endParaRPr>
                     </a:p>
                   </a:txBody>
-                  <a:tcPr marL="66675" marR="66675" marT="66675" marB="66675" anchor="t">
+                  <a:tcPr marL="66675" marR="66675" marT="66675" marB="66675">
                     <a:lnL w="12700" cap="flat" cmpd="sng" algn="ctr">
                       <a:solidFill>
                         <a:srgbClr val="C4C3BE"/>
@@ -13333,7 +13294,7 @@
                     <a:bodyPr/>
                     <a:lstStyle/>
                     <a:p>
-                      <a:pPr indent="0" marL="0">
+                      <a:pPr marL="0" indent="0">
                         <a:lnSpc>
                           <a:spcPts val="2100"/>
                         </a:lnSpc>
@@ -13357,7 +13318,7 @@
                       </a:endParaRPr>
                     </a:p>
                   </a:txBody>
-                  <a:tcPr marL="66675" marR="66675" marT="66675" marB="66675" anchor="t">
+                  <a:tcPr marL="66675" marR="66675" marT="66675" marB="66675">
                     <a:lnL w="12700" cap="flat" cmpd="sng" algn="ctr">
                       <a:solidFill>
                         <a:srgbClr val="C4C3BE"/>
@@ -13396,6 +13357,11 @@
                     </a:lnB>
                   </a:tcPr>
                 </a:tc>
+                <a:extLst>
+                  <a:ext uri="{0D108BD9-81ED-4DB2-BD59-A6C34878D82A}">
+                    <a16:rowId xmlns:a16="http://schemas.microsoft.com/office/drawing/2014/main" val="10005"/>
+                  </a:ext>
+                </a:extLst>
               </a:tr>
               <a:tr h="411532">
                 <a:tc>
@@ -13403,7 +13369,7 @@
                     <a:bodyPr/>
                     <a:lstStyle/>
                     <a:p>
-                      <a:pPr indent="0" marL="0">
+                      <a:pPr marL="0" indent="0">
                         <a:lnSpc>
                           <a:spcPts val="2100"/>
                         </a:lnSpc>
@@ -13427,7 +13393,7 @@
                       </a:endParaRPr>
                     </a:p>
                   </a:txBody>
-                  <a:tcPr marL="66675" marR="66675" marT="66675" marB="66675" anchor="t">
+                  <a:tcPr marL="66675" marR="66675" marT="66675" marB="66675">
                     <a:lnL w="12700" cap="flat" cmpd="sng" algn="ctr">
                       <a:solidFill>
                         <a:srgbClr val="C4C3BE"/>
@@ -13474,7 +13440,7 @@
                     <a:bodyPr/>
                     <a:lstStyle/>
                     <a:p>
-                      <a:pPr indent="0" marL="0">
+                      <a:pPr marL="0" indent="0">
                         <a:lnSpc>
                           <a:spcPts val="2100"/>
                         </a:lnSpc>
@@ -13498,7 +13464,7 @@
                       </a:endParaRPr>
                     </a:p>
                   </a:txBody>
-                  <a:tcPr marL="66675" marR="66675" marT="66675" marB="66675" anchor="t">
+                  <a:tcPr marL="66675" marR="66675" marT="66675" marB="66675">
                     <a:lnL w="12700" cap="flat" cmpd="sng" algn="ctr">
                       <a:solidFill>
                         <a:srgbClr val="BBB8AE"/>
@@ -13540,6 +13506,11 @@
                     </a:solidFill>
                   </a:tcPr>
                 </a:tc>
+                <a:extLst>
+                  <a:ext uri="{0D108BD9-81ED-4DB2-BD59-A6C34878D82A}">
+                    <a16:rowId xmlns:a16="http://schemas.microsoft.com/office/drawing/2014/main" val="10006"/>
+                  </a:ext>
+                </a:extLst>
               </a:tr>
             </a:tbl>
           </a:graphicData>
@@ -13568,7 +13539,7 @@
           </a:bodyPr>
           <a:lstStyle/>
           <a:p>
-            <a:pPr algn="l" indent="0" marL="0">
+            <a:pPr marL="0" indent="0" algn="l">
               <a:lnSpc>
                 <a:spcPts val="2100"/>
               </a:lnSpc>
@@ -13612,7 +13583,7 @@
           </a:bodyPr>
           <a:lstStyle/>
           <a:p>
-            <a:pPr algn="l" indent="0" marL="0">
+            <a:pPr marL="0" indent="0" algn="l">
               <a:lnSpc>
                 <a:spcPts val="1680"/>
               </a:lnSpc>
@@ -13656,7 +13627,7 @@
           </a:bodyPr>
           <a:lstStyle/>
           <a:p>
-            <a:pPr algn="r" indent="0" marL="0">
+            <a:pPr marL="0" indent="0" algn="r">
               <a:lnSpc>
                 <a:spcPts val="1680"/>
               </a:lnSpc>
@@ -13973,4 +13944,319 @@
   <a:objectDefaults/>
   <a:extraClrSchemeLst/>
 </a:theme>
+</file>
+
+<file path=ppt/theme/theme2.xml><?xml version="1.0" encoding="utf-8"?>
+<a:theme xmlns:a="http://schemas.openxmlformats.org/drawingml/2006/main" name="Office Theme">
+  <a:themeElements>
+    <a:clrScheme name="Office">
+      <a:dk1>
+        <a:sysClr val="windowText" lastClr="000000"/>
+      </a:dk1>
+      <a:lt1>
+        <a:sysClr val="window" lastClr="FFFFFF"/>
+      </a:lt1>
+      <a:dk2>
+        <a:srgbClr val="0E2841"/>
+      </a:dk2>
+      <a:lt2>
+        <a:srgbClr val="E8E8E8"/>
+      </a:lt2>
+      <a:accent1>
+        <a:srgbClr val="156082"/>
+      </a:accent1>
+      <a:accent2>
+        <a:srgbClr val="E97132"/>
+      </a:accent2>
+      <a:accent3>
+        <a:srgbClr val="196B24"/>
+      </a:accent3>
+      <a:accent4>
+        <a:srgbClr val="0F9ED5"/>
+      </a:accent4>
+      <a:accent5>
+        <a:srgbClr val="A02B93"/>
+      </a:accent5>
+      <a:accent6>
+        <a:srgbClr val="4EA72E"/>
+      </a:accent6>
+      <a:hlink>
+        <a:srgbClr val="467886"/>
+      </a:hlink>
+      <a:folHlink>
+        <a:srgbClr val="96607D"/>
+      </a:folHlink>
+    </a:clrScheme>
+    <a:fontScheme name="Office">
+      <a:majorFont>
+        <a:latin typeface="Aptos Display" panose="02110004020202020204"/>
+        <a:ea typeface=""/>
+        <a:cs typeface=""/>
+        <a:font script="Jpan" typeface="游ゴシック Light"/>
+        <a:font script="Hang" typeface="맑은 고딕"/>
+        <a:font script="Hans" typeface="等线 Light"/>
+        <a:font script="Hant" typeface="新細明體"/>
+        <a:font script="Arab" typeface="Times New Roman"/>
+        <a:font script="Hebr" typeface="Times New Roman"/>
+        <a:font script="Thai" typeface="Angsana New"/>
+        <a:font script="Ethi" typeface="Nyala"/>
+        <a:font script="Beng" typeface="Vrinda"/>
+        <a:font script="Gujr" typeface="Shruti"/>
+        <a:font script="Khmr" typeface="MoolBoran"/>
+        <a:font script="Knda" typeface="Tunga"/>
+        <a:font script="Guru" typeface="Raavi"/>
+        <a:font script="Cans" typeface="Euphemia"/>
+        <a:font script="Cher" typeface="Plantagenet Cherokee"/>
+        <a:font script="Yiii" typeface="Microsoft Yi Baiti"/>
+        <a:font script="Tibt" typeface="Microsoft Himalaya"/>
+        <a:font script="Thaa" typeface="MV Boli"/>
+        <a:font script="Deva" typeface="Mangal"/>
+        <a:font script="Telu" typeface="Gautami"/>
+        <a:font script="Taml" typeface="Latha"/>
+        <a:font script="Syrc" typeface="Estrangelo Edessa"/>
+        <a:font script="Orya" typeface="Kalinga"/>
+        <a:font script="Mlym" typeface="Kartika"/>
+        <a:font script="Laoo" typeface="DokChampa"/>
+        <a:font script="Sinh" typeface="Iskoola Pota"/>
+        <a:font script="Mong" typeface="Mongolian Baiti"/>
+        <a:font script="Viet" typeface="Times New Roman"/>
+        <a:font script="Uigh" typeface="Microsoft Uighur"/>
+        <a:font script="Geor" typeface="Sylfaen"/>
+        <a:font script="Armn" typeface="Arial"/>
+        <a:font script="Bugi" typeface="Leelawadee UI"/>
+        <a:font script="Bopo" typeface="Microsoft JhengHei"/>
+        <a:font script="Java" typeface="Javanese Text"/>
+        <a:font script="Lisu" typeface="Segoe UI"/>
+        <a:font script="Mymr" typeface="Myanmar Text"/>
+        <a:font script="Nkoo" typeface="Ebrima"/>
+        <a:font script="Olck" typeface="Nirmala UI"/>
+        <a:font script="Osma" typeface="Ebrima"/>
+        <a:font script="Phag" typeface="Phagspa"/>
+        <a:font script="Syrn" typeface="Estrangelo Edessa"/>
+        <a:font script="Syrj" typeface="Estrangelo Edessa"/>
+        <a:font script="Syre" typeface="Estrangelo Edessa"/>
+        <a:font script="Sora" typeface="Nirmala UI"/>
+        <a:font script="Tale" typeface="Microsoft Tai Le"/>
+        <a:font script="Talu" typeface="Microsoft New Tai Lue"/>
+        <a:font script="Tfng" typeface="Ebrima"/>
+      </a:majorFont>
+      <a:minorFont>
+        <a:latin typeface="Aptos" panose="02110004020202020204"/>
+        <a:ea typeface=""/>
+        <a:cs typeface=""/>
+        <a:font script="Jpan" typeface="游ゴシック"/>
+        <a:font script="Hang" typeface="맑은 고딕"/>
+        <a:font script="Hans" typeface="等线"/>
+        <a:font script="Hant" typeface="新細明體"/>
+        <a:font script="Arab" typeface="Arial"/>
+        <a:font script="Hebr" typeface="Arial"/>
+        <a:font script="Thai" typeface="Cordia New"/>
+        <a:font script="Ethi" typeface="Nyala"/>
+        <a:font script="Beng" typeface="Vrinda"/>
+        <a:font script="Gujr" typeface="Shruti"/>
+        <a:font script="Khmr" typeface="DaunPenh"/>
+        <a:font script="Knda" typeface="Tunga"/>
+        <a:font script="Guru" typeface="Raavi"/>
+        <a:font script="Cans" typeface="Euphemia"/>
+        <a:font script="Cher" typeface="Plantagenet Cherokee"/>
+        <a:font script="Yiii" typeface="Microsoft Yi Baiti"/>
+        <a:font script="Tibt" typeface="Microsoft Himalaya"/>
+        <a:font script="Thaa" typeface="MV Boli"/>
+        <a:font script="Deva" typeface="Mangal"/>
+        <a:font script="Telu" typeface="Gautami"/>
+        <a:font script="Taml" typeface="Latha"/>
+        <a:font script="Syrc" typeface="Estrangelo Edessa"/>
+        <a:font script="Orya" typeface="Kalinga"/>
+        <a:font script="Mlym" typeface="Kartika"/>
+        <a:font script="Laoo" typeface="DokChampa"/>
+        <a:font script="Sinh" typeface="Iskoola Pota"/>
+        <a:font script="Mong" typeface="Mongolian Baiti"/>
+        <a:font script="Viet" typeface="Arial"/>
+        <a:font script="Uigh" typeface="Microsoft Uighur"/>
+        <a:font script="Geor" typeface="Sylfaen"/>
+        <a:font script="Armn" typeface="Arial"/>
+        <a:font script="Bugi" typeface="Leelawadee UI"/>
+        <a:font script="Bopo" typeface="Microsoft JhengHei"/>
+        <a:font script="Java" typeface="Javanese Text"/>
+        <a:font script="Lisu" typeface="Segoe UI"/>
+        <a:font script="Mymr" typeface="Myanmar Text"/>
+        <a:font script="Nkoo" typeface="Ebrima"/>
+        <a:font script="Olck" typeface="Nirmala UI"/>
+        <a:font script="Osma" typeface="Ebrima"/>
+        <a:font script="Phag" typeface="Phagspa"/>
+        <a:font script="Syrn" typeface="Estrangelo Edessa"/>
+        <a:font script="Syrj" typeface="Estrangelo Edessa"/>
+        <a:font script="Syre" typeface="Estrangelo Edessa"/>
+        <a:font script="Sora" typeface="Nirmala UI"/>
+        <a:font script="Tale" typeface="Microsoft Tai Le"/>
+        <a:font script="Talu" typeface="Microsoft New Tai Lue"/>
+        <a:font script="Tfng" typeface="Ebrima"/>
+      </a:minorFont>
+    </a:fontScheme>
+    <a:fmtScheme name="Office">
+      <a:fillStyleLst>
+        <a:solidFill>
+          <a:schemeClr val="phClr"/>
+        </a:solidFill>
+        <a:gradFill rotWithShape="1">
+          <a:gsLst>
+            <a:gs pos="0">
+              <a:schemeClr val="phClr">
+                <a:lumMod val="110000"/>
+                <a:satMod val="105000"/>
+                <a:tint val="67000"/>
+              </a:schemeClr>
+            </a:gs>
+            <a:gs pos="50000">
+              <a:schemeClr val="phClr">
+                <a:lumMod val="105000"/>
+                <a:satMod val="103000"/>
+                <a:tint val="73000"/>
+              </a:schemeClr>
+            </a:gs>
+            <a:gs pos="100000">
+              <a:schemeClr val="phClr">
+                <a:lumMod val="105000"/>
+                <a:satMod val="109000"/>
+                <a:tint val="81000"/>
+              </a:schemeClr>
+            </a:gs>
+          </a:gsLst>
+          <a:lin ang="5400000" scaled="0"/>
+        </a:gradFill>
+        <a:gradFill rotWithShape="1">
+          <a:gsLst>
+            <a:gs pos="0">
+              <a:schemeClr val="phClr">
+                <a:satMod val="103000"/>
+                <a:lumMod val="102000"/>
+                <a:tint val="94000"/>
+              </a:schemeClr>
+            </a:gs>
+            <a:gs pos="50000">
+              <a:schemeClr val="phClr">
+                <a:satMod val="110000"/>
+                <a:lumMod val="100000"/>
+                <a:shade val="100000"/>
+              </a:schemeClr>
+            </a:gs>
+            <a:gs pos="100000">
+              <a:schemeClr val="phClr">
+                <a:lumMod val="99000"/>
+                <a:satMod val="120000"/>
+                <a:shade val="78000"/>
+              </a:schemeClr>
+            </a:gs>
+          </a:gsLst>
+          <a:lin ang="5400000" scaled="0"/>
+        </a:gradFill>
+      </a:fillStyleLst>
+      <a:lnStyleLst>
+        <a:ln w="12700" cap="flat" cmpd="sng" algn="ctr">
+          <a:solidFill>
+            <a:schemeClr val="phClr"/>
+          </a:solidFill>
+          <a:prstDash val="solid"/>
+          <a:miter lim="800000"/>
+        </a:ln>
+        <a:ln w="19050" cap="flat" cmpd="sng" algn="ctr">
+          <a:solidFill>
+            <a:schemeClr val="phClr"/>
+          </a:solidFill>
+          <a:prstDash val="solid"/>
+          <a:miter lim="800000"/>
+        </a:ln>
+        <a:ln w="25400" cap="flat" cmpd="sng" algn="ctr">
+          <a:solidFill>
+            <a:schemeClr val="phClr"/>
+          </a:solidFill>
+          <a:prstDash val="solid"/>
+          <a:miter lim="800000"/>
+        </a:ln>
+      </a:lnStyleLst>
+      <a:effectStyleLst>
+        <a:effectStyle>
+          <a:effectLst/>
+        </a:effectStyle>
+        <a:effectStyle>
+          <a:effectLst/>
+        </a:effectStyle>
+        <a:effectStyle>
+          <a:effectLst>
+            <a:outerShdw blurRad="57150" dist="19050" dir="5400000" algn="ctr" rotWithShape="0">
+              <a:srgbClr val="000000">
+                <a:alpha val="63000"/>
+              </a:srgbClr>
+            </a:outerShdw>
+          </a:effectLst>
+        </a:effectStyle>
+      </a:effectStyleLst>
+      <a:bgFillStyleLst>
+        <a:solidFill>
+          <a:schemeClr val="phClr"/>
+        </a:solidFill>
+        <a:solidFill>
+          <a:schemeClr val="phClr">
+            <a:tint val="95000"/>
+            <a:satMod val="170000"/>
+          </a:schemeClr>
+        </a:solidFill>
+        <a:gradFill rotWithShape="1">
+          <a:gsLst>
+            <a:gs pos="0">
+              <a:schemeClr val="phClr">
+                <a:tint val="93000"/>
+                <a:satMod val="150000"/>
+                <a:shade val="98000"/>
+                <a:lumMod val="102000"/>
+              </a:schemeClr>
+            </a:gs>
+            <a:gs pos="50000">
+              <a:schemeClr val="phClr">
+                <a:tint val="98000"/>
+                <a:satMod val="130000"/>
+                <a:shade val="90000"/>
+                <a:lumMod val="103000"/>
+              </a:schemeClr>
+            </a:gs>
+            <a:gs pos="100000">
+              <a:schemeClr val="phClr">
+                <a:shade val="63000"/>
+                <a:satMod val="120000"/>
+              </a:schemeClr>
+            </a:gs>
+          </a:gsLst>
+          <a:lin ang="5400000" scaled="0"/>
+        </a:gradFill>
+      </a:bgFillStyleLst>
+    </a:fmtScheme>
+  </a:themeElements>
+  <a:objectDefaults>
+    <a:lnDef>
+      <a:spPr/>
+      <a:bodyPr/>
+      <a:lstStyle/>
+      <a:style>
+        <a:lnRef idx="2">
+          <a:schemeClr val="accent1"/>
+        </a:lnRef>
+        <a:fillRef idx="0">
+          <a:schemeClr val="accent1"/>
+        </a:fillRef>
+        <a:effectRef idx="1">
+          <a:schemeClr val="accent1"/>
+        </a:effectRef>
+        <a:fontRef idx="minor">
+          <a:schemeClr val="tx1"/>
+        </a:fontRef>
+      </a:style>
+    </a:lnDef>
+  </a:objectDefaults>
+  <a:extraClrSchemeLst/>
+  <a:extLst>
+    <a:ext uri="{05A4C25C-085E-4340-85A3-A5531E510DB2}">
+      <thm15:themeFamily xmlns:thm15="http://schemas.microsoft.com/office/thememl/2012/main" name="Office Theme" id="{2E142A2C-CD16-42D6-873A-C26D2A0506FA}" vid="{1BDDFF52-6CD6-40A5-AB3C-68EB2F1E4D0A}"/>
+    </a:ext>
+  </a:extLst>
+</a:theme>
 </file>
</xml_diff>